<commit_message>
fixed small typo in presentation
</commit_message>
<xml_diff>
--- a/rag_presentation.pptx
+++ b/rag_presentation.pptx
@@ -120,6 +120,11 @@
       </a:defRPr>
     </a:lvl9pPr>
   </p:defaultTextStyle>
+  <p:extLst>
+    <p:ext uri="{EFAFB233-063F-42B5-8137-9DF3F51BA10A}">
+      <p15:sldGuideLst xmlns:p15="http://schemas.microsoft.com/office/powerpoint/2012/main"/>
+    </p:ext>
+  </p:extLst>
 </p:presentation>
 </file>
 
@@ -7777,11 +7782,11 @@
   <p:clrMapOvr>
     <a:masterClrMapping/>
   </p:clrMapOvr>
-  <mc:AlternateContent xmlns:mc="http://schemas.openxmlformats.org/markup-compatibility/2006">
-    <mc:Choice xmlns:p14="http://schemas.microsoft.com/office/powerpoint/2010/main" Requires="p14">
+  <mc:AlternateContent xmlns:mc="http://schemas.openxmlformats.org/markup-compatibility/2006" xmlns:p14="http://schemas.microsoft.com/office/powerpoint/2010/main">
+    <mc:Choice Requires="p14">
       <p:transition spd="slow" p14:dur="2000"/>
     </mc:Choice>
-    <mc:Fallback>
+    <mc:Fallback xmlns="">
       <p:transition spd="slow"/>
     </mc:Fallback>
   </mc:AlternateContent>
@@ -11023,7 +11028,15 @@
             </a:pPr>
             <a:r>
               <a:rPr lang="bg-BG" dirty="0" smtClean="0"/>
-              <a:t>Разделяне на секция на подсекции с  максимално дължина 1500 символа</a:t>
+              <a:t>Разделяне на секция на подсекции с  </a:t>
+            </a:r>
+            <a:r>
+              <a:rPr lang="bg-BG" dirty="0" smtClean="0"/>
+              <a:t>максимална </a:t>
+            </a:r>
+            <a:r>
+              <a:rPr lang="bg-BG" dirty="0" smtClean="0"/>
+              <a:t>дължина 1500 символа</a:t>
             </a:r>
             <a:r>
               <a:rPr lang="en-US" dirty="0" smtClean="0"/>
@@ -11059,7 +11072,15 @@
             </a:pPr>
             <a:r>
               <a:rPr lang="bg-BG" dirty="0" smtClean="0"/>
-              <a:t>Съхраняване на подходящи метаданни за всяка подсекция</a:t>
+              <a:t>Съхраняване на подходящи метаданни за всяка </a:t>
+            </a:r>
+            <a:r>
+              <a:rPr lang="bg-BG" dirty="0" smtClean="0"/>
+              <a:t>подсекция</a:t>
+            </a:r>
+            <a:r>
+              <a:rPr lang="en-US"/>
+              <a:t>.</a:t>
             </a:r>
             <a:endParaRPr lang="bg-BG" dirty="0"/>
           </a:p>

</xml_diff>

<commit_message>
Changes to the presentation
</commit_message>
<xml_diff>
--- a/rag_presentation.pptx
+++ b/rag_presentation.pptx
@@ -172,7 +172,7 @@
           </a:lstStyle>
           <a:p>
             <a:r>
-              <a:rPr lang="en-US" smtClean="0"/>
+              <a:rPr lang="en-US"/>
               <a:t>Click to edit Master title style</a:t>
             </a:r>
             <a:endParaRPr lang="en-US" dirty="0"/>
@@ -292,7 +292,7 @@
           </a:lstStyle>
           <a:p>
             <a:r>
-              <a:rPr lang="en-US" smtClean="0"/>
+              <a:rPr lang="en-US"/>
               <a:t>Click to edit Master subtitle style</a:t>
             </a:r>
             <a:endParaRPr lang="en-US" dirty="0"/>
@@ -316,7 +316,7 @@
           <a:p>
             <a:fld id="{27B09BD0-848F-4EBB-A109-7353F2339BC4}" type="datetimeFigureOut">
               <a:rPr lang="bg-BG" smtClean="0"/>
-              <a:t>9.6.2026 г.</a:t>
+              <a:t>10.6.2026 г.</a:t>
             </a:fld>
             <a:endParaRPr lang="bg-BG"/>
           </a:p>
@@ -422,6 +422,13 @@
             <a:noFill/>
           </a:ln>
         </p:spPr>
+        <p:txBody>
+          <a:bodyPr/>
+          <a:lstStyle/>
+          <a:p>
+            <a:endParaRPr lang="en-US"/>
+          </a:p>
+        </p:txBody>
       </p:sp>
       <p:sp>
         <p:nvSpPr>
@@ -508,7 +515,7 @@
           </a:lstStyle>
           <a:p>
             <a:r>
-              <a:rPr lang="en-US" smtClean="0"/>
+              <a:rPr lang="en-US"/>
               <a:t>Click to edit Master title style</a:t>
             </a:r>
             <a:endParaRPr lang="en-US" dirty="0"/>
@@ -631,7 +638,7 @@
           <a:p>
             <a:pPr lvl="0"/>
             <a:r>
-              <a:rPr lang="en-US" smtClean="0"/>
+              <a:rPr lang="en-US"/>
               <a:t>Edit Master text styles</a:t>
             </a:r>
           </a:p>
@@ -654,7 +661,7 @@
           <a:p>
             <a:fld id="{27B09BD0-848F-4EBB-A109-7353F2339BC4}" type="datetimeFigureOut">
               <a:rPr lang="bg-BG" smtClean="0"/>
-              <a:t>9.6.2026 г.</a:t>
+              <a:t>10.6.2026 г.</a:t>
             </a:fld>
             <a:endParaRPr lang="bg-BG"/>
           </a:p>
@@ -846,7 +853,7 @@
           </a:lstStyle>
           <a:p>
             <a:r>
-              <a:rPr lang="en-US" smtClean="0"/>
+              <a:rPr lang="en-US"/>
               <a:t>Click to edit Master title style</a:t>
             </a:r>
             <a:endParaRPr lang="en-US" dirty="0"/>
@@ -910,7 +917,7 @@
           <a:p>
             <a:pPr lvl="0"/>
             <a:r>
-              <a:rPr lang="en-US" smtClean="0"/>
+              <a:rPr lang="en-US"/>
               <a:t>Edit Master text styles</a:t>
             </a:r>
           </a:p>
@@ -1032,7 +1039,7 @@
           <a:p>
             <a:pPr lvl="0"/>
             <a:r>
-              <a:rPr lang="en-US" smtClean="0"/>
+              <a:rPr lang="en-US"/>
               <a:t>Edit Master text styles</a:t>
             </a:r>
           </a:p>
@@ -1055,7 +1062,7 @@
           <a:p>
             <a:fld id="{27B09BD0-848F-4EBB-A109-7353F2339BC4}" type="datetimeFigureOut">
               <a:rPr lang="bg-BG" smtClean="0"/>
-              <a:t>9.6.2026 г.</a:t>
+              <a:t>10.6.2026 г.</a:t>
             </a:fld>
             <a:endParaRPr lang="bg-BG"/>
           </a:p>
@@ -1323,7 +1330,7 @@
           </a:lstStyle>
           <a:p>
             <a:r>
-              <a:rPr lang="en-US" smtClean="0"/>
+              <a:rPr lang="en-US"/>
               <a:t>Click to edit Master title style</a:t>
             </a:r>
             <a:endParaRPr lang="en-US" dirty="0"/>
@@ -1368,7 +1375,7 @@
               <a:buNone/>
             </a:pPr>
             <a:r>
-              <a:rPr lang="en-US" smtClean="0"/>
+              <a:rPr lang="en-US"/>
               <a:t>Edit Master text styles</a:t>
             </a:r>
           </a:p>
@@ -1391,7 +1398,7 @@
           <a:p>
             <a:fld id="{27B09BD0-848F-4EBB-A109-7353F2339BC4}" type="datetimeFigureOut">
               <a:rPr lang="bg-BG" smtClean="0"/>
-              <a:t>9.6.2026 г.</a:t>
+              <a:t>10.6.2026 г.</a:t>
             </a:fld>
             <a:endParaRPr lang="bg-BG"/>
           </a:p>
@@ -1583,7 +1590,7 @@
           </a:lstStyle>
           <a:p>
             <a:r>
-              <a:rPr lang="en-US" smtClean="0"/>
+              <a:rPr lang="en-US"/>
               <a:t>Click to edit Master title style</a:t>
             </a:r>
             <a:endParaRPr lang="en-US" dirty="0"/>
@@ -1644,7 +1651,7 @@
           <a:p>
             <a:pPr lvl="0"/>
             <a:r>
-              <a:rPr lang="en-US" smtClean="0"/>
+              <a:rPr lang="en-US"/>
               <a:t>Edit Master text styles</a:t>
             </a:r>
           </a:p>
@@ -1688,7 +1695,7 @@
               <a:buNone/>
             </a:pPr>
             <a:r>
-              <a:rPr lang="en-US" smtClean="0"/>
+              <a:rPr lang="en-US"/>
               <a:t>Edit Master text styles</a:t>
             </a:r>
           </a:p>
@@ -1711,7 +1718,7 @@
           <a:p>
             <a:fld id="{27B09BD0-848F-4EBB-A109-7353F2339BC4}" type="datetimeFigureOut">
               <a:rPr lang="bg-BG" smtClean="0"/>
-              <a:t>9.6.2026 г.</a:t>
+              <a:t>10.6.2026 г.</a:t>
             </a:fld>
             <a:endParaRPr lang="bg-BG"/>
           </a:p>
@@ -1979,7 +1986,7 @@
           </a:lstStyle>
           <a:p>
             <a:r>
-              <a:rPr lang="en-US" smtClean="0"/>
+              <a:rPr lang="en-US"/>
               <a:t>Click to edit Master title style</a:t>
             </a:r>
             <a:endParaRPr lang="en-US" dirty="0"/>
@@ -2040,7 +2047,7 @@
           <a:p>
             <a:pPr lvl="0"/>
             <a:r>
-              <a:rPr lang="en-US" smtClean="0"/>
+              <a:rPr lang="en-US"/>
               <a:t>Edit Master text styles</a:t>
             </a:r>
           </a:p>
@@ -2084,7 +2091,7 @@
               <a:buNone/>
             </a:pPr>
             <a:r>
-              <a:rPr lang="en-US" smtClean="0"/>
+              <a:rPr lang="en-US"/>
               <a:t>Edit Master text styles</a:t>
             </a:r>
           </a:p>
@@ -2107,7 +2114,7 @@
           <a:p>
             <a:fld id="{27B09BD0-848F-4EBB-A109-7353F2339BC4}" type="datetimeFigureOut">
               <a:rPr lang="bg-BG" smtClean="0"/>
-              <a:t>9.6.2026 г.</a:t>
+              <a:t>10.6.2026 г.</a:t>
             </a:fld>
             <a:endParaRPr lang="bg-BG"/>
           </a:p>
@@ -2288,7 +2295,7 @@
           <a:lstStyle/>
           <a:p>
             <a:r>
-              <a:rPr lang="en-US" smtClean="0"/>
+              <a:rPr lang="en-US"/>
               <a:t>Click to edit Master title style</a:t>
             </a:r>
             <a:endParaRPr lang="en-US" dirty="0"/>
@@ -2312,35 +2319,35 @@
           <a:p>
             <a:pPr lvl="0"/>
             <a:r>
-              <a:rPr lang="en-US" smtClean="0"/>
+              <a:rPr lang="en-US"/>
               <a:t>Edit Master text styles</a:t>
             </a:r>
           </a:p>
           <a:p>
             <a:pPr lvl="1"/>
             <a:r>
-              <a:rPr lang="en-US" smtClean="0"/>
+              <a:rPr lang="en-US"/>
               <a:t>Second level</a:t>
             </a:r>
           </a:p>
           <a:p>
             <a:pPr lvl="2"/>
             <a:r>
-              <a:rPr lang="en-US" smtClean="0"/>
+              <a:rPr lang="en-US"/>
               <a:t>Third level</a:t>
             </a:r>
           </a:p>
           <a:p>
             <a:pPr lvl="3"/>
             <a:r>
-              <a:rPr lang="en-US" smtClean="0"/>
+              <a:rPr lang="en-US"/>
               <a:t>Fourth level</a:t>
             </a:r>
           </a:p>
           <a:p>
             <a:pPr lvl="4"/>
             <a:r>
-              <a:rPr lang="en-US" smtClean="0"/>
+              <a:rPr lang="en-US"/>
               <a:t>Fifth level</a:t>
             </a:r>
             <a:endParaRPr lang="en-US" dirty="0"/>
@@ -2364,7 +2371,7 @@
           <a:p>
             <a:fld id="{27B09BD0-848F-4EBB-A109-7353F2339BC4}" type="datetimeFigureOut">
               <a:rPr lang="bg-BG" smtClean="0"/>
-              <a:t>9.6.2026 г.</a:t>
+              <a:t>10.6.2026 г.</a:t>
             </a:fld>
             <a:endParaRPr lang="bg-BG"/>
           </a:p>
@@ -2545,7 +2552,7 @@
           <a:lstStyle/>
           <a:p>
             <a:r>
-              <a:rPr lang="en-US" smtClean="0"/>
+              <a:rPr lang="en-US"/>
               <a:t>Click to edit Master title style</a:t>
             </a:r>
             <a:endParaRPr lang="en-US" dirty="0"/>
@@ -2574,35 +2581,35 @@
           <a:p>
             <a:pPr lvl="0"/>
             <a:r>
-              <a:rPr lang="en-US" smtClean="0"/>
+              <a:rPr lang="en-US"/>
               <a:t>Edit Master text styles</a:t>
             </a:r>
           </a:p>
           <a:p>
             <a:pPr lvl="1"/>
             <a:r>
-              <a:rPr lang="en-US" smtClean="0"/>
+              <a:rPr lang="en-US"/>
               <a:t>Second level</a:t>
             </a:r>
           </a:p>
           <a:p>
             <a:pPr lvl="2"/>
             <a:r>
-              <a:rPr lang="en-US" smtClean="0"/>
+              <a:rPr lang="en-US"/>
               <a:t>Third level</a:t>
             </a:r>
           </a:p>
           <a:p>
             <a:pPr lvl="3"/>
             <a:r>
-              <a:rPr lang="en-US" smtClean="0"/>
+              <a:rPr lang="en-US"/>
               <a:t>Fourth level</a:t>
             </a:r>
           </a:p>
           <a:p>
             <a:pPr lvl="4"/>
             <a:r>
-              <a:rPr lang="en-US" smtClean="0"/>
+              <a:rPr lang="en-US"/>
               <a:t>Fifth level</a:t>
             </a:r>
             <a:endParaRPr lang="en-US" dirty="0"/>
@@ -2626,7 +2633,7 @@
           <a:p>
             <a:fld id="{27B09BD0-848F-4EBB-A109-7353F2339BC4}" type="datetimeFigureOut">
               <a:rPr lang="bg-BG" smtClean="0"/>
-              <a:t>9.6.2026 г.</a:t>
+              <a:t>10.6.2026 г.</a:t>
             </a:fld>
             <a:endParaRPr lang="bg-BG"/>
           </a:p>
@@ -2807,7 +2814,7 @@
           <a:lstStyle/>
           <a:p>
             <a:r>
-              <a:rPr lang="en-US" smtClean="0"/>
+              <a:rPr lang="en-US"/>
               <a:t>Click to edit Master title style</a:t>
             </a:r>
             <a:endParaRPr lang="en-US" dirty="0"/>
@@ -2836,35 +2843,35 @@
           <a:p>
             <a:pPr lvl="0"/>
             <a:r>
-              <a:rPr lang="en-US" smtClean="0"/>
+              <a:rPr lang="en-US"/>
               <a:t>Edit Master text styles</a:t>
             </a:r>
           </a:p>
           <a:p>
             <a:pPr lvl="1"/>
             <a:r>
-              <a:rPr lang="en-US" smtClean="0"/>
+              <a:rPr lang="en-US"/>
               <a:t>Second level</a:t>
             </a:r>
           </a:p>
           <a:p>
             <a:pPr lvl="2"/>
             <a:r>
-              <a:rPr lang="en-US" smtClean="0"/>
+              <a:rPr lang="en-US"/>
               <a:t>Third level</a:t>
             </a:r>
           </a:p>
           <a:p>
             <a:pPr lvl="3"/>
             <a:r>
-              <a:rPr lang="en-US" smtClean="0"/>
+              <a:rPr lang="en-US"/>
               <a:t>Fourth level</a:t>
             </a:r>
           </a:p>
           <a:p>
             <a:pPr lvl="4"/>
             <a:r>
-              <a:rPr lang="en-US" smtClean="0"/>
+              <a:rPr lang="en-US"/>
               <a:t>Fifth level</a:t>
             </a:r>
             <a:endParaRPr lang="en-US" dirty="0"/>
@@ -2888,7 +2895,7 @@
           <a:p>
             <a:fld id="{27B09BD0-848F-4EBB-A109-7353F2339BC4}" type="datetimeFigureOut">
               <a:rPr lang="bg-BG" smtClean="0"/>
-              <a:t>9.6.2026 г.</a:t>
+              <a:t>10.6.2026 г.</a:t>
             </a:fld>
             <a:endParaRPr lang="bg-BG"/>
           </a:p>
@@ -2994,6 +3001,13 @@
             <a:noFill/>
           </a:ln>
         </p:spPr>
+        <p:txBody>
+          <a:bodyPr/>
+          <a:lstStyle/>
+          <a:p>
+            <a:endParaRPr lang="en-US"/>
+          </a:p>
+        </p:txBody>
       </p:sp>
       <p:sp>
         <p:nvSpPr>
@@ -3073,7 +3087,7 @@
           </a:lstStyle>
           <a:p>
             <a:r>
-              <a:rPr lang="en-US" smtClean="0"/>
+              <a:rPr lang="en-US"/>
               <a:t>Click to edit Master title style</a:t>
             </a:r>
             <a:endParaRPr lang="en-US" dirty="0"/>
@@ -3194,7 +3208,7 @@
           <a:p>
             <a:pPr lvl="0"/>
             <a:r>
-              <a:rPr lang="en-US" smtClean="0"/>
+              <a:rPr lang="en-US"/>
               <a:t>Edit Master text styles</a:t>
             </a:r>
           </a:p>
@@ -3217,7 +3231,7 @@
           <a:p>
             <a:fld id="{27B09BD0-848F-4EBB-A109-7353F2339BC4}" type="datetimeFigureOut">
               <a:rPr lang="bg-BG" smtClean="0"/>
-              <a:t>9.6.2026 г.</a:t>
+              <a:t>10.6.2026 г.</a:t>
             </a:fld>
             <a:endParaRPr lang="bg-BG"/>
           </a:p>
@@ -3398,7 +3412,7 @@
           <a:lstStyle/>
           <a:p>
             <a:r>
-              <a:rPr lang="en-US" smtClean="0"/>
+              <a:rPr lang="en-US"/>
               <a:t>Click to edit Master title style</a:t>
             </a:r>
             <a:endParaRPr lang="en-US" dirty="0"/>
@@ -3429,35 +3443,35 @@
           <a:p>
             <a:pPr lvl="0"/>
             <a:r>
-              <a:rPr lang="en-US" smtClean="0"/>
+              <a:rPr lang="en-US"/>
               <a:t>Edit Master text styles</a:t>
             </a:r>
           </a:p>
           <a:p>
             <a:pPr lvl="1"/>
             <a:r>
-              <a:rPr lang="en-US" smtClean="0"/>
+              <a:rPr lang="en-US"/>
               <a:t>Second level</a:t>
             </a:r>
           </a:p>
           <a:p>
             <a:pPr lvl="2"/>
             <a:r>
-              <a:rPr lang="en-US" smtClean="0"/>
+              <a:rPr lang="en-US"/>
               <a:t>Third level</a:t>
             </a:r>
           </a:p>
           <a:p>
             <a:pPr lvl="3"/>
             <a:r>
-              <a:rPr lang="en-US" smtClean="0"/>
+              <a:rPr lang="en-US"/>
               <a:t>Fourth level</a:t>
             </a:r>
           </a:p>
           <a:p>
             <a:pPr lvl="4"/>
             <a:r>
-              <a:rPr lang="en-US" smtClean="0"/>
+              <a:rPr lang="en-US"/>
               <a:t>Fifth level</a:t>
             </a:r>
             <a:endParaRPr lang="en-US" dirty="0"/>
@@ -3488,35 +3502,35 @@
           <a:p>
             <a:pPr lvl="0"/>
             <a:r>
-              <a:rPr lang="en-US" smtClean="0"/>
+              <a:rPr lang="en-US"/>
               <a:t>Edit Master text styles</a:t>
             </a:r>
           </a:p>
           <a:p>
             <a:pPr lvl="1"/>
             <a:r>
-              <a:rPr lang="en-US" smtClean="0"/>
+              <a:rPr lang="en-US"/>
               <a:t>Second level</a:t>
             </a:r>
           </a:p>
           <a:p>
             <a:pPr lvl="2"/>
             <a:r>
-              <a:rPr lang="en-US" smtClean="0"/>
+              <a:rPr lang="en-US"/>
               <a:t>Third level</a:t>
             </a:r>
           </a:p>
           <a:p>
             <a:pPr lvl="3"/>
             <a:r>
-              <a:rPr lang="en-US" smtClean="0"/>
+              <a:rPr lang="en-US"/>
               <a:t>Fourth level</a:t>
             </a:r>
           </a:p>
           <a:p>
             <a:pPr lvl="4"/>
             <a:r>
-              <a:rPr lang="en-US" smtClean="0"/>
+              <a:rPr lang="en-US"/>
               <a:t>Fifth level</a:t>
             </a:r>
             <a:endParaRPr lang="en-US" dirty="0"/>
@@ -3540,7 +3554,7 @@
           <a:p>
             <a:fld id="{27B09BD0-848F-4EBB-A109-7353F2339BC4}" type="datetimeFigureOut">
               <a:rPr lang="bg-BG" smtClean="0"/>
-              <a:t>9.6.2026 г.</a:t>
+              <a:t>10.6.2026 г.</a:t>
             </a:fld>
             <a:endParaRPr lang="bg-BG"/>
           </a:p>
@@ -3646,6 +3660,13 @@
             <a:noFill/>
           </a:ln>
         </p:spPr>
+        <p:txBody>
+          <a:bodyPr/>
+          <a:lstStyle/>
+          <a:p>
+            <a:endParaRPr lang="en-US"/>
+          </a:p>
+        </p:txBody>
       </p:sp>
       <p:sp>
         <p:nvSpPr>
@@ -3721,7 +3742,7 @@
           <a:lstStyle/>
           <a:p>
             <a:r>
-              <a:rPr lang="en-US" smtClean="0"/>
+              <a:rPr lang="en-US"/>
               <a:t>Click to edit Master title style</a:t>
             </a:r>
             <a:endParaRPr lang="en-US" dirty="0"/>
@@ -3789,7 +3810,7 @@
           <a:p>
             <a:pPr lvl="0"/>
             <a:r>
-              <a:rPr lang="en-US" smtClean="0"/>
+              <a:rPr lang="en-US"/>
               <a:t>Edit Master text styles</a:t>
             </a:r>
           </a:p>
@@ -3819,35 +3840,35 @@
           <a:p>
             <a:pPr lvl="0"/>
             <a:r>
-              <a:rPr lang="en-US" smtClean="0"/>
+              <a:rPr lang="en-US"/>
               <a:t>Edit Master text styles</a:t>
             </a:r>
           </a:p>
           <a:p>
             <a:pPr lvl="1"/>
             <a:r>
-              <a:rPr lang="en-US" smtClean="0"/>
+              <a:rPr lang="en-US"/>
               <a:t>Second level</a:t>
             </a:r>
           </a:p>
           <a:p>
             <a:pPr lvl="2"/>
             <a:r>
-              <a:rPr lang="en-US" smtClean="0"/>
+              <a:rPr lang="en-US"/>
               <a:t>Third level</a:t>
             </a:r>
           </a:p>
           <a:p>
             <a:pPr lvl="3"/>
             <a:r>
-              <a:rPr lang="en-US" smtClean="0"/>
+              <a:rPr lang="en-US"/>
               <a:t>Fourth level</a:t>
             </a:r>
           </a:p>
           <a:p>
             <a:pPr lvl="4"/>
             <a:r>
-              <a:rPr lang="en-US" smtClean="0"/>
+              <a:rPr lang="en-US"/>
               <a:t>Fifth level</a:t>
             </a:r>
             <a:endParaRPr lang="en-US" dirty="0"/>
@@ -3915,7 +3936,7 @@
           <a:p>
             <a:pPr lvl="0"/>
             <a:r>
-              <a:rPr lang="en-US" smtClean="0"/>
+              <a:rPr lang="en-US"/>
               <a:t>Edit Master text styles</a:t>
             </a:r>
           </a:p>
@@ -3945,35 +3966,35 @@
           <a:p>
             <a:pPr lvl="0"/>
             <a:r>
-              <a:rPr lang="en-US" smtClean="0"/>
+              <a:rPr lang="en-US"/>
               <a:t>Edit Master text styles</a:t>
             </a:r>
           </a:p>
           <a:p>
             <a:pPr lvl="1"/>
             <a:r>
-              <a:rPr lang="en-US" smtClean="0"/>
+              <a:rPr lang="en-US"/>
               <a:t>Second level</a:t>
             </a:r>
           </a:p>
           <a:p>
             <a:pPr lvl="2"/>
             <a:r>
-              <a:rPr lang="en-US" smtClean="0"/>
+              <a:rPr lang="en-US"/>
               <a:t>Third level</a:t>
             </a:r>
           </a:p>
           <a:p>
             <a:pPr lvl="3"/>
             <a:r>
-              <a:rPr lang="en-US" smtClean="0"/>
+              <a:rPr lang="en-US"/>
               <a:t>Fourth level</a:t>
             </a:r>
           </a:p>
           <a:p>
             <a:pPr lvl="4"/>
             <a:r>
-              <a:rPr lang="en-US" smtClean="0"/>
+              <a:rPr lang="en-US"/>
               <a:t>Fifth level</a:t>
             </a:r>
             <a:endParaRPr lang="en-US" dirty="0"/>
@@ -3997,7 +4018,7 @@
           <a:p>
             <a:fld id="{27B09BD0-848F-4EBB-A109-7353F2339BC4}" type="datetimeFigureOut">
               <a:rPr lang="bg-BG" smtClean="0"/>
-              <a:t>9.6.2026 г.</a:t>
+              <a:t>10.6.2026 г.</a:t>
             </a:fld>
             <a:endParaRPr lang="bg-BG"/>
           </a:p>
@@ -4103,6 +4124,13 @@
             <a:noFill/>
           </a:ln>
         </p:spPr>
+        <p:txBody>
+          <a:bodyPr/>
+          <a:lstStyle/>
+          <a:p>
+            <a:endParaRPr lang="en-US"/>
+          </a:p>
+        </p:txBody>
       </p:sp>
       <p:sp>
         <p:nvSpPr>
@@ -4178,7 +4206,7 @@
           <a:lstStyle/>
           <a:p>
             <a:r>
-              <a:rPr lang="en-US" smtClean="0"/>
+              <a:rPr lang="en-US"/>
               <a:t>Click to edit Master title style</a:t>
             </a:r>
             <a:endParaRPr lang="en-US" dirty="0"/>
@@ -4202,7 +4230,7 @@
           <a:p>
             <a:fld id="{27B09BD0-848F-4EBB-A109-7353F2339BC4}" type="datetimeFigureOut">
               <a:rPr lang="bg-BG" smtClean="0"/>
-              <a:t>9.6.2026 г.</a:t>
+              <a:t>10.6.2026 г.</a:t>
             </a:fld>
             <a:endParaRPr lang="bg-BG"/>
           </a:p>
@@ -4379,7 +4407,7 @@
           <a:p>
             <a:fld id="{27B09BD0-848F-4EBB-A109-7353F2339BC4}" type="datetimeFigureOut">
               <a:rPr lang="bg-BG" smtClean="0"/>
-              <a:t>9.6.2026 г.</a:t>
+              <a:t>10.6.2026 г.</a:t>
             </a:fld>
             <a:endParaRPr lang="bg-BG"/>
           </a:p>
@@ -4564,7 +4592,7 @@
           </a:lstStyle>
           <a:p>
             <a:r>
-              <a:rPr lang="en-US" smtClean="0"/>
+              <a:rPr lang="en-US"/>
               <a:t>Click to edit Master title style</a:t>
             </a:r>
             <a:endParaRPr lang="en-US" dirty="0"/>
@@ -4595,35 +4623,35 @@
           <a:p>
             <a:pPr lvl="0"/>
             <a:r>
-              <a:rPr lang="en-US" smtClean="0"/>
+              <a:rPr lang="en-US"/>
               <a:t>Edit Master text styles</a:t>
             </a:r>
           </a:p>
           <a:p>
             <a:pPr lvl="1"/>
             <a:r>
-              <a:rPr lang="en-US" smtClean="0"/>
+              <a:rPr lang="en-US"/>
               <a:t>Second level</a:t>
             </a:r>
           </a:p>
           <a:p>
             <a:pPr lvl="2"/>
             <a:r>
-              <a:rPr lang="en-US" smtClean="0"/>
+              <a:rPr lang="en-US"/>
               <a:t>Third level</a:t>
             </a:r>
           </a:p>
           <a:p>
             <a:pPr lvl="3"/>
             <a:r>
-              <a:rPr lang="en-US" smtClean="0"/>
+              <a:rPr lang="en-US"/>
               <a:t>Fourth level</a:t>
             </a:r>
           </a:p>
           <a:p>
             <a:pPr lvl="4"/>
             <a:r>
-              <a:rPr lang="en-US" smtClean="0"/>
+              <a:rPr lang="en-US"/>
               <a:t>Fifth level</a:t>
             </a:r>
             <a:endParaRPr lang="en-US" dirty="0"/>
@@ -4689,7 +4717,7 @@
           <a:p>
             <a:pPr lvl="0"/>
             <a:r>
-              <a:rPr lang="en-US" smtClean="0"/>
+              <a:rPr lang="en-US"/>
               <a:t>Edit Master text styles</a:t>
             </a:r>
           </a:p>
@@ -4712,7 +4740,7 @@
           <a:p>
             <a:fld id="{27B09BD0-848F-4EBB-A109-7353F2339BC4}" type="datetimeFigureOut">
               <a:rPr lang="bg-BG" smtClean="0"/>
-              <a:t>9.6.2026 г.</a:t>
+              <a:t>10.6.2026 г.</a:t>
             </a:fld>
             <a:endParaRPr lang="bg-BG"/>
           </a:p>
@@ -4899,7 +4927,7 @@
           </a:lstStyle>
           <a:p>
             <a:r>
-              <a:rPr lang="en-US" smtClean="0"/>
+              <a:rPr lang="en-US"/>
               <a:t>Click to edit Master title style</a:t>
             </a:r>
             <a:endParaRPr lang="en-US" dirty="0"/>
@@ -4966,7 +4994,7 @@
           </a:lstStyle>
           <a:p>
             <a:r>
-              <a:rPr lang="en-US" smtClean="0"/>
+              <a:rPr lang="en-US"/>
               <a:t>Click icon to add picture</a:t>
             </a:r>
             <a:endParaRPr lang="en-US" dirty="0"/>
@@ -5034,7 +5062,7 @@
           <a:p>
             <a:pPr lvl="0"/>
             <a:r>
-              <a:rPr lang="en-US" smtClean="0"/>
+              <a:rPr lang="en-US"/>
               <a:t>Edit Master text styles</a:t>
             </a:r>
           </a:p>
@@ -5057,7 +5085,7 @@
           <a:p>
             <a:fld id="{27B09BD0-848F-4EBB-A109-7353F2339BC4}" type="datetimeFigureOut">
               <a:rPr lang="bg-BG" smtClean="0"/>
-              <a:t>9.6.2026 г.</a:t>
+              <a:t>10.6.2026 г.</a:t>
             </a:fld>
             <a:endParaRPr lang="bg-BG"/>
           </a:p>
@@ -5301,6 +5329,13 @@
               <a:noFill/>
             </a:ln>
           </p:spPr>
+          <p:txBody>
+            <a:bodyPr/>
+            <a:lstStyle/>
+            <a:p>
+              <a:endParaRPr lang="en-US"/>
+            </a:p>
+          </p:txBody>
         </p:sp>
         <p:sp>
           <p:nvSpPr>
@@ -5367,6 +5402,13 @@
               <a:noFill/>
             </a:ln>
           </p:spPr>
+          <p:txBody>
+            <a:bodyPr/>
+            <a:lstStyle/>
+            <a:p>
+              <a:endParaRPr lang="en-US"/>
+            </a:p>
+          </p:txBody>
         </p:sp>
         <p:sp>
           <p:nvSpPr>
@@ -5438,6 +5480,13 @@
               <a:noFill/>
             </a:ln>
           </p:spPr>
+          <p:txBody>
+            <a:bodyPr/>
+            <a:lstStyle/>
+            <a:p>
+              <a:endParaRPr lang="en-US"/>
+            </a:p>
+          </p:txBody>
         </p:sp>
         <p:sp>
           <p:nvSpPr>
@@ -5489,6 +5538,13 @@
               <a:noFill/>
             </a:ln>
           </p:spPr>
+          <p:txBody>
+            <a:bodyPr/>
+            <a:lstStyle/>
+            <a:p>
+              <a:endParaRPr lang="en-US"/>
+            </a:p>
+          </p:txBody>
         </p:sp>
         <p:sp>
           <p:nvSpPr>
@@ -5575,6 +5631,13 @@
               <a:noFill/>
             </a:ln>
           </p:spPr>
+          <p:txBody>
+            <a:bodyPr/>
+            <a:lstStyle/>
+            <a:p>
+              <a:endParaRPr lang="en-US"/>
+            </a:p>
+          </p:txBody>
         </p:sp>
         <p:sp>
           <p:nvSpPr>
@@ -5656,6 +5719,13 @@
               <a:noFill/>
             </a:ln>
           </p:spPr>
+          <p:txBody>
+            <a:bodyPr/>
+            <a:lstStyle/>
+            <a:p>
+              <a:endParaRPr lang="en-US"/>
+            </a:p>
+          </p:txBody>
         </p:sp>
         <p:sp>
           <p:nvSpPr>
@@ -5717,6 +5787,13 @@
               <a:noFill/>
             </a:ln>
           </p:spPr>
+          <p:txBody>
+            <a:bodyPr/>
+            <a:lstStyle/>
+            <a:p>
+              <a:endParaRPr lang="en-US"/>
+            </a:p>
+          </p:txBody>
         </p:sp>
         <p:sp>
           <p:nvSpPr>
@@ -5798,6 +5875,13 @@
               <a:noFill/>
             </a:ln>
           </p:spPr>
+          <p:txBody>
+            <a:bodyPr/>
+            <a:lstStyle/>
+            <a:p>
+              <a:endParaRPr lang="en-US"/>
+            </a:p>
+          </p:txBody>
         </p:sp>
         <p:sp>
           <p:nvSpPr>
@@ -5914,6 +5998,13 @@
               <a:noFill/>
             </a:ln>
           </p:spPr>
+          <p:txBody>
+            <a:bodyPr/>
+            <a:lstStyle/>
+            <a:p>
+              <a:endParaRPr lang="en-US"/>
+            </a:p>
+          </p:txBody>
         </p:sp>
         <p:sp>
           <p:nvSpPr>
@@ -5965,6 +6056,13 @@
               <a:noFill/>
             </a:ln>
           </p:spPr>
+          <p:txBody>
+            <a:bodyPr/>
+            <a:lstStyle/>
+            <a:p>
+              <a:endParaRPr lang="en-US"/>
+            </a:p>
+          </p:txBody>
         </p:sp>
         <p:sp>
           <p:nvSpPr>
@@ -6026,6 +6124,13 @@
               <a:noFill/>
             </a:ln>
           </p:spPr>
+          <p:txBody>
+            <a:bodyPr/>
+            <a:lstStyle/>
+            <a:p>
+              <a:endParaRPr lang="en-US"/>
+            </a:p>
+          </p:txBody>
         </p:sp>
         <p:sp>
           <p:nvSpPr>
@@ -6097,6 +6202,13 @@
               <a:noFill/>
             </a:ln>
           </p:spPr>
+          <p:txBody>
+            <a:bodyPr/>
+            <a:lstStyle/>
+            <a:p>
+              <a:endParaRPr lang="en-US"/>
+            </a:p>
+          </p:txBody>
         </p:sp>
       </p:grpSp>
       <p:grpSp>
@@ -6216,6 +6328,13 @@
               <a:noFill/>
             </a:ln>
           </p:spPr>
+          <p:txBody>
+            <a:bodyPr/>
+            <a:lstStyle/>
+            <a:p>
+              <a:endParaRPr lang="en-US"/>
+            </a:p>
+          </p:txBody>
         </p:sp>
         <p:sp>
           <p:nvSpPr>
@@ -6285,6 +6404,13 @@
               <a:noFill/>
             </a:ln>
           </p:spPr>
+          <p:txBody>
+            <a:bodyPr/>
+            <a:lstStyle/>
+            <a:p>
+              <a:endParaRPr lang="en-US"/>
+            </a:p>
+          </p:txBody>
         </p:sp>
         <p:sp>
           <p:nvSpPr>
@@ -6354,6 +6480,13 @@
               <a:noFill/>
             </a:ln>
           </p:spPr>
+          <p:txBody>
+            <a:bodyPr/>
+            <a:lstStyle/>
+            <a:p>
+              <a:endParaRPr lang="en-US"/>
+            </a:p>
+          </p:txBody>
         </p:sp>
         <p:sp>
           <p:nvSpPr>
@@ -6438,6 +6571,13 @@
               <a:noFill/>
             </a:ln>
           </p:spPr>
+          <p:txBody>
+            <a:bodyPr/>
+            <a:lstStyle/>
+            <a:p>
+              <a:endParaRPr lang="en-US"/>
+            </a:p>
+          </p:txBody>
         </p:sp>
         <p:sp>
           <p:nvSpPr>
@@ -6532,6 +6672,13 @@
               <a:noFill/>
             </a:ln>
           </p:spPr>
+          <p:txBody>
+            <a:bodyPr/>
+            <a:lstStyle/>
+            <a:p>
+              <a:endParaRPr lang="en-US"/>
+            </a:p>
+          </p:txBody>
         </p:sp>
         <p:sp>
           <p:nvSpPr>
@@ -6581,6 +6728,13 @@
               <a:noFill/>
             </a:ln>
           </p:spPr>
+          <p:txBody>
+            <a:bodyPr/>
+            <a:lstStyle/>
+            <a:p>
+              <a:endParaRPr lang="en-US"/>
+            </a:p>
+          </p:txBody>
         </p:sp>
         <p:sp>
           <p:nvSpPr>
@@ -6645,6 +6799,13 @@
               <a:noFill/>
             </a:ln>
           </p:spPr>
+          <p:txBody>
+            <a:bodyPr/>
+            <a:lstStyle/>
+            <a:p>
+              <a:endParaRPr lang="en-US"/>
+            </a:p>
+          </p:txBody>
         </p:sp>
         <p:sp>
           <p:nvSpPr>
@@ -6754,6 +6915,13 @@
               <a:noFill/>
             </a:ln>
           </p:spPr>
+          <p:txBody>
+            <a:bodyPr/>
+            <a:lstStyle/>
+            <a:p>
+              <a:endParaRPr lang="en-US"/>
+            </a:p>
+          </p:txBody>
         </p:sp>
         <p:sp>
           <p:nvSpPr>
@@ -6803,6 +6971,13 @@
               <a:noFill/>
             </a:ln>
           </p:spPr>
+          <p:txBody>
+            <a:bodyPr/>
+            <a:lstStyle/>
+            <a:p>
+              <a:endParaRPr lang="en-US"/>
+            </a:p>
+          </p:txBody>
         </p:sp>
         <p:sp>
           <p:nvSpPr>
@@ -6872,6 +7047,13 @@
               <a:noFill/>
             </a:ln>
           </p:spPr>
+          <p:txBody>
+            <a:bodyPr/>
+            <a:lstStyle/>
+            <a:p>
+              <a:endParaRPr lang="en-US"/>
+            </a:p>
+          </p:txBody>
         </p:sp>
         <p:sp>
           <p:nvSpPr>
@@ -6936,6 +7118,13 @@
               <a:noFill/>
             </a:ln>
           </p:spPr>
+          <p:txBody>
+            <a:bodyPr/>
+            <a:lstStyle/>
+            <a:p>
+              <a:endParaRPr lang="en-US"/>
+            </a:p>
+          </p:txBody>
         </p:sp>
         <p:sp>
           <p:nvSpPr>
@@ -7005,6 +7194,13 @@
               <a:noFill/>
             </a:ln>
           </p:spPr>
+          <p:txBody>
+            <a:bodyPr/>
+            <a:lstStyle/>
+            <a:p>
+              <a:endParaRPr lang="en-US"/>
+            </a:p>
+          </p:txBody>
         </p:sp>
       </p:grpSp>
       <p:sp>
@@ -7043,6 +7239,13 @@
             <a:schemeClr val="lt1"/>
           </a:fontRef>
         </p:style>
+        <p:txBody>
+          <a:bodyPr/>
+          <a:lstStyle/>
+          <a:p>
+            <a:endParaRPr lang="en-US"/>
+          </a:p>
+        </p:txBody>
       </p:sp>
       <p:sp>
         <p:nvSpPr>
@@ -7070,7 +7273,7 @@
           <a:lstStyle/>
           <a:p>
             <a:r>
-              <a:rPr lang="en-US" smtClean="0"/>
+              <a:rPr lang="en-US"/>
               <a:t>Click to edit Master title style</a:t>
             </a:r>
             <a:endParaRPr lang="en-US" dirty="0"/>
@@ -7104,35 +7307,35 @@
           <a:p>
             <a:pPr lvl="0"/>
             <a:r>
-              <a:rPr lang="en-US" smtClean="0"/>
+              <a:rPr lang="en-US"/>
               <a:t>Edit Master text styles</a:t>
             </a:r>
           </a:p>
           <a:p>
             <a:pPr lvl="1"/>
             <a:r>
-              <a:rPr lang="en-US" smtClean="0"/>
+              <a:rPr lang="en-US"/>
               <a:t>Second level</a:t>
             </a:r>
           </a:p>
           <a:p>
             <a:pPr lvl="2"/>
             <a:r>
-              <a:rPr lang="en-US" smtClean="0"/>
+              <a:rPr lang="en-US"/>
               <a:t>Third level</a:t>
             </a:r>
           </a:p>
           <a:p>
             <a:pPr lvl="3"/>
             <a:r>
-              <a:rPr lang="en-US" smtClean="0"/>
+              <a:rPr lang="en-US"/>
               <a:t>Fourth level</a:t>
             </a:r>
           </a:p>
           <a:p>
             <a:pPr lvl="4"/>
             <a:r>
-              <a:rPr lang="en-US" smtClean="0"/>
+              <a:rPr lang="en-US"/>
               <a:t>Fifth level</a:t>
             </a:r>
             <a:endParaRPr lang="en-US" dirty="0"/>
@@ -7174,7 +7377,7 @@
           <a:p>
             <a:fld id="{27B09BD0-848F-4EBB-A109-7353F2339BC4}" type="datetimeFigureOut">
               <a:rPr lang="bg-BG" smtClean="0"/>
-              <a:t>9.6.2026 г.</a:t>
+              <a:t>10.6.2026 г.</a:t>
             </a:fld>
             <a:endParaRPr lang="bg-BG"/>
           </a:p>
@@ -7713,14 +7916,13 @@
           <a:lstStyle/>
           <a:p>
             <a:r>
-              <a:rPr lang="en-US" dirty="0" smtClean="0"/>
+              <a:rPr lang="en-US" dirty="0"/>
               <a:t>RAG </a:t>
             </a:r>
             <a:r>
-              <a:rPr lang="bg-BG" dirty="0" smtClean="0"/>
+              <a:rPr lang="bg-BG" dirty="0"/>
               <a:t>асистент за лекарства</a:t>
             </a:r>
-            <a:endParaRPr lang="bg-BG" dirty="0"/>
           </a:p>
         </p:txBody>
       </p:sp>
@@ -7745,30 +7947,29 @@
           <a:lstStyle/>
           <a:p>
             <a:r>
-              <a:rPr lang="bg-BG" dirty="0" smtClean="0"/>
+              <a:rPr lang="bg-BG" dirty="0"/>
               <a:t>Стилиян Кожухаров</a:t>
             </a:r>
             <a:r>
-              <a:rPr lang="en-US" dirty="0" smtClean="0"/>
+              <a:rPr lang="en-US" dirty="0"/>
               <a:t>, </a:t>
             </a:r>
             <a:r>
-              <a:rPr lang="bg-BG" dirty="0" smtClean="0"/>
+              <a:rPr lang="bg-BG" dirty="0"/>
               <a:t>Илиян </a:t>
             </a:r>
             <a:r>
-              <a:rPr lang="bg-BG" dirty="0" err="1" smtClean="0"/>
+              <a:rPr lang="bg-BG" dirty="0" err="1"/>
               <a:t>Свечев</a:t>
             </a:r>
             <a:r>
-              <a:rPr lang="en-US" dirty="0" smtClean="0"/>
+              <a:rPr lang="en-US" dirty="0"/>
               <a:t>, </a:t>
             </a:r>
             <a:r>
-              <a:rPr lang="bg-BG" dirty="0" smtClean="0"/>
+              <a:rPr lang="bg-BG" dirty="0"/>
               <a:t>Самуил Илиев</a:t>
             </a:r>
-            <a:endParaRPr lang="bg-BG" dirty="0"/>
           </a:p>
         </p:txBody>
       </p:sp>
@@ -7782,21 +7983,6 @@
   <p:clrMapOvr>
     <a:masterClrMapping/>
   </p:clrMapOvr>
-  <mc:AlternateContent xmlns:mc="http://schemas.openxmlformats.org/markup-compatibility/2006" xmlns:p14="http://schemas.microsoft.com/office/powerpoint/2010/main">
-    <mc:Choice Requires="p14">
-      <p:transition spd="slow" p14:dur="2000"/>
-    </mc:Choice>
-    <mc:Fallback xmlns="">
-      <p:transition spd="slow"/>
-    </mc:Fallback>
-  </mc:AlternateContent>
-  <p:timing>
-    <p:tnLst>
-      <p:par>
-        <p:cTn id="1" dur="indefinite" restart="never" nodeType="tmRoot"/>
-      </p:par>
-    </p:tnLst>
-  </p:timing>
 </p:sld>
 </file>
 
@@ -7833,10 +8019,9 @@
           <a:lstStyle/>
           <a:p>
             <a:r>
-              <a:rPr lang="bg-BG" dirty="0" smtClean="0"/>
+              <a:rPr lang="bg-BG" dirty="0"/>
               <a:t>Извличане и генериране</a:t>
             </a:r>
-            <a:endParaRPr lang="bg-BG" dirty="0"/>
           </a:p>
         </p:txBody>
       </p:sp>
@@ -7856,14 +8041,13 @@
           <a:lstStyle/>
           <a:p>
             <a:r>
-              <a:rPr lang="en-US" dirty="0" smtClean="0"/>
+              <a:rPr lang="en-US" dirty="0"/>
               <a:t>// TODO – </a:t>
             </a:r>
             <a:r>
-              <a:rPr lang="bg-BG" dirty="0" smtClean="0"/>
+              <a:rPr lang="bg-BG" dirty="0"/>
               <a:t>Сами добави тук каквото сметнеш за нужно</a:t>
             </a:r>
-            <a:endParaRPr lang="bg-BG" dirty="0"/>
           </a:p>
         </p:txBody>
       </p:sp>
@@ -7877,13 +8061,18 @@
   <p:clrMapOvr>
     <a:masterClrMapping/>
   </p:clrMapOvr>
-  <p:timing>
-    <p:tnLst>
-      <p:par>
-        <p:cTn id="1" dur="indefinite" restart="never" nodeType="tmRoot"/>
-      </p:par>
-    </p:tnLst>
-  </p:timing>
+  <mc:AlternateContent xmlns:mc="http://schemas.openxmlformats.org/markup-compatibility/2006">
+    <mc:Choice xmlns:p15="http://schemas.microsoft.com/office/powerpoint/2012/main" Requires="p15">
+      <p:transition xmlns:p14="http://schemas.microsoft.com/office/powerpoint/2010/main" spd="slow" p14:dur="1250">
+        <p15:prstTrans prst="pageCurlDouble"/>
+      </p:transition>
+    </mc:Choice>
+    <mc:Fallback>
+      <p:transition spd="slow">
+        <p:fade/>
+      </p:transition>
+    </mc:Fallback>
+  </mc:AlternateContent>
 </p:sld>
 </file>
 
@@ -7925,25 +8114,20 @@
           <a:lstStyle/>
           <a:p>
             <a:r>
-              <a:rPr lang="bg-BG" dirty="0" smtClean="0"/>
+              <a:rPr lang="bg-BG" dirty="0"/>
               <a:t>Използвани технологии</a:t>
-            </a:r>
-            <a:r>
-              <a:rPr lang="en-US" dirty="0"/>
-              <a:t/>
             </a:r>
             <a:br>
               <a:rPr lang="en-US" dirty="0"/>
             </a:br>
             <a:r>
-              <a:rPr lang="en-US" dirty="0" smtClean="0"/>
+              <a:rPr lang="en-US" dirty="0"/>
               <a:t>// TODO – </a:t>
             </a:r>
             <a:r>
-              <a:rPr lang="bg-BG" dirty="0" smtClean="0"/>
+              <a:rPr lang="bg-BG" dirty="0"/>
               <a:t>добавете разни работи</a:t>
             </a:r>
-            <a:endParaRPr lang="bg-BG" dirty="0"/>
           </a:p>
         </p:txBody>
       </p:sp>
@@ -7995,10 +8179,9 @@
                     <a:lstStyle/>
                     <a:p>
                       <a:r>
-                        <a:rPr lang="bg-BG" dirty="0" smtClean="0"/>
+                        <a:rPr lang="bg-BG" dirty="0"/>
                         <a:t>Технология</a:t>
                       </a:r>
-                      <a:endParaRPr lang="bg-BG" dirty="0"/>
                     </a:p>
                   </a:txBody>
                   <a:tcPr/>
@@ -8009,11 +8192,11 @@
                     <a:lstStyle/>
                     <a:p>
                       <a:r>
-                        <a:rPr lang="bg-BG" dirty="0" smtClean="0"/>
+                        <a:rPr lang="bg-BG" dirty="0"/>
                         <a:t>Роля</a:t>
                       </a:r>
                       <a:r>
-                        <a:rPr lang="bg-BG" baseline="0" dirty="0" smtClean="0"/>
+                        <a:rPr lang="bg-BG" baseline="0" dirty="0"/>
                         <a:t> в проекта</a:t>
                       </a:r>
                       <a:endParaRPr lang="bg-BG" dirty="0"/>
@@ -8034,7 +8217,7 @@
                     <a:lstStyle/>
                     <a:p>
                       <a:r>
-                        <a:rPr lang="en-US" dirty="0" smtClean="0"/>
+                        <a:rPr lang="en-US" dirty="0"/>
                         <a:t>Python</a:t>
                       </a:r>
                       <a:endParaRPr lang="bg-BG" dirty="0"/>
@@ -8048,59 +8231,59 @@
                     <a:lstStyle/>
                     <a:p>
                       <a:r>
-                        <a:rPr lang="ru-RU" dirty="0" err="1" smtClean="0"/>
+                        <a:rPr lang="ru-RU" dirty="0" err="1"/>
                         <a:t>Основен</a:t>
                       </a:r>
                       <a:r>
-                        <a:rPr lang="ru-RU" dirty="0" smtClean="0"/>
+                        <a:rPr lang="ru-RU" dirty="0"/>
                         <a:t> </a:t>
                       </a:r>
                       <a:r>
-                        <a:rPr lang="ru-RU" dirty="0" err="1" smtClean="0"/>
+                        <a:rPr lang="ru-RU" dirty="0" err="1"/>
                         <a:t>език</a:t>
                       </a:r>
                       <a:r>
-                        <a:rPr lang="ru-RU" dirty="0" smtClean="0"/>
+                        <a:rPr lang="ru-RU" dirty="0"/>
                         <a:t> за обработка на </a:t>
                       </a:r>
                       <a:r>
-                        <a:rPr lang="ru-RU" dirty="0" err="1" smtClean="0"/>
+                        <a:rPr lang="ru-RU" dirty="0" err="1"/>
                         <a:t>данните</a:t>
                       </a:r>
                       <a:r>
-                        <a:rPr lang="ru-RU" dirty="0" smtClean="0"/>
+                        <a:rPr lang="ru-RU" dirty="0"/>
                         <a:t>, </a:t>
                       </a:r>
                       <a:r>
-                        <a:rPr lang="ru-RU" dirty="0" err="1" smtClean="0"/>
+                        <a:rPr lang="ru-RU" dirty="0" err="1"/>
                         <a:t>изграждане</a:t>
                       </a:r>
                       <a:r>
-                        <a:rPr lang="ru-RU" dirty="0" smtClean="0"/>
+                        <a:rPr lang="ru-RU" dirty="0"/>
                         <a:t> на RAG </a:t>
                       </a:r>
                       <a:r>
-                        <a:rPr lang="ru-RU" dirty="0" err="1" smtClean="0"/>
+                        <a:rPr lang="ru-RU" dirty="0" err="1"/>
                         <a:t>pipeline</a:t>
                       </a:r>
                       <a:r>
-                        <a:rPr lang="ru-RU" dirty="0" smtClean="0"/>
+                        <a:rPr lang="ru-RU" dirty="0"/>
                         <a:t> и интеграция на </a:t>
                       </a:r>
                       <a:r>
-                        <a:rPr lang="ru-RU" dirty="0" err="1" smtClean="0"/>
+                        <a:rPr lang="ru-RU" dirty="0" err="1"/>
                         <a:t>всички</a:t>
                       </a:r>
                       <a:r>
-                        <a:rPr lang="ru-RU" dirty="0" smtClean="0"/>
+                        <a:rPr lang="ru-RU" dirty="0"/>
                         <a:t> </a:t>
                       </a:r>
                       <a:r>
-                        <a:rPr lang="ru-RU" dirty="0" err="1" smtClean="0"/>
+                        <a:rPr lang="ru-RU" dirty="0" err="1"/>
                         <a:t>компоненти</a:t>
                       </a:r>
                       <a:r>
-                        <a:rPr lang="ru-RU" dirty="0" smtClean="0"/>
+                        <a:rPr lang="ru-RU" dirty="0"/>
                         <a:t>.</a:t>
                       </a:r>
                       <a:endParaRPr lang="bg-BG" dirty="0"/>
@@ -8121,7 +8304,7 @@
                     <a:lstStyle/>
                     <a:p>
                       <a:r>
-                        <a:rPr lang="en-US" dirty="0" err="1" smtClean="0"/>
+                        <a:rPr lang="en-US" dirty="0" err="1"/>
                         <a:t>RapidFuzz</a:t>
                       </a:r>
                       <a:endParaRPr lang="bg-BG" dirty="0"/>
@@ -8135,51 +8318,51 @@
                     <a:lstStyle/>
                     <a:p>
                       <a:r>
-                        <a:rPr lang="ru-RU" dirty="0" err="1" smtClean="0"/>
+                        <a:rPr lang="ru-RU" dirty="0" err="1"/>
                         <a:t>Използван</a:t>
                       </a:r>
                       <a:r>
-                        <a:rPr lang="ru-RU" dirty="0" smtClean="0"/>
+                        <a:rPr lang="ru-RU" dirty="0"/>
                         <a:t> за </a:t>
                       </a:r>
                       <a:r>
-                        <a:rPr lang="ru-RU" dirty="0" err="1" smtClean="0"/>
+                        <a:rPr lang="ru-RU" dirty="0" err="1"/>
                         <a:t>fuzzy</a:t>
                       </a:r>
                       <a:r>
-                        <a:rPr lang="ru-RU" dirty="0" smtClean="0"/>
+                        <a:rPr lang="ru-RU" dirty="0"/>
                         <a:t> </a:t>
                       </a:r>
                       <a:r>
-                        <a:rPr lang="ru-RU" dirty="0" err="1" smtClean="0"/>
+                        <a:rPr lang="ru-RU" dirty="0" err="1"/>
                         <a:t>matching</a:t>
                       </a:r>
                       <a:r>
-                        <a:rPr lang="ru-RU" dirty="0" smtClean="0"/>
+                        <a:rPr lang="ru-RU" dirty="0"/>
                         <a:t> на </a:t>
                       </a:r>
                       <a:r>
-                        <a:rPr lang="ru-RU" dirty="0" err="1" smtClean="0"/>
+                        <a:rPr lang="ru-RU" dirty="0" err="1"/>
                         <a:t>заглавията</a:t>
                       </a:r>
                       <a:r>
-                        <a:rPr lang="ru-RU" dirty="0" smtClean="0"/>
+                        <a:rPr lang="ru-RU" dirty="0"/>
                         <a:t> на </a:t>
                       </a:r>
                       <a:r>
-                        <a:rPr lang="ru-RU" dirty="0" err="1" smtClean="0"/>
+                        <a:rPr lang="ru-RU" dirty="0" err="1"/>
                         <a:t>секциите</a:t>
                       </a:r>
                       <a:r>
-                        <a:rPr lang="ru-RU" dirty="0" smtClean="0"/>
+                        <a:rPr lang="ru-RU" dirty="0"/>
                         <a:t> при грешки от </a:t>
                       </a:r>
                       <a:r>
-                        <a:rPr lang="ru-RU" dirty="0" err="1" smtClean="0"/>
+                        <a:rPr lang="ru-RU" dirty="0" err="1"/>
                         <a:t>извличането</a:t>
                       </a:r>
                       <a:r>
-                        <a:rPr lang="ru-RU" dirty="0" smtClean="0"/>
+                        <a:rPr lang="ru-RU" dirty="0"/>
                         <a:t> на текста от PDF.</a:t>
                       </a:r>
                       <a:endParaRPr lang="bg-BG" dirty="0"/>
@@ -8200,7 +8383,7 @@
                     <a:lstStyle/>
                     <a:p>
                       <a:r>
-                        <a:rPr lang="en-US" dirty="0" smtClean="0"/>
+                        <a:rPr lang="en-US" dirty="0"/>
                         <a:t>gemma3:4b</a:t>
                       </a:r>
                       <a:endParaRPr lang="bg-BG" dirty="0"/>
@@ -8214,43 +8397,43 @@
                     <a:lstStyle/>
                     <a:p>
                       <a:r>
-                        <a:rPr lang="ru-RU" dirty="0" err="1" smtClean="0"/>
+                        <a:rPr lang="ru-RU" dirty="0" err="1"/>
                         <a:t>Генерира</a:t>
                       </a:r>
                       <a:r>
-                        <a:rPr lang="ru-RU" dirty="0" smtClean="0"/>
+                        <a:rPr lang="ru-RU" dirty="0"/>
                         <a:t> </a:t>
                       </a:r>
                       <a:r>
-                        <a:rPr lang="ru-RU" dirty="0" err="1" smtClean="0"/>
+                        <a:rPr lang="ru-RU" dirty="0" err="1"/>
                         <a:t>естествени</a:t>
                       </a:r>
                       <a:r>
-                        <a:rPr lang="ru-RU" dirty="0" smtClean="0"/>
+                        <a:rPr lang="ru-RU" dirty="0"/>
                         <a:t> отговори на </a:t>
                       </a:r>
                       <a:r>
-                        <a:rPr lang="ru-RU" dirty="0" err="1" smtClean="0"/>
+                        <a:rPr lang="ru-RU" dirty="0" err="1"/>
                         <a:t>български</a:t>
                       </a:r>
                       <a:r>
-                        <a:rPr lang="ru-RU" dirty="0" smtClean="0"/>
+                        <a:rPr lang="ru-RU" dirty="0"/>
                         <a:t> </a:t>
                       </a:r>
                       <a:r>
-                        <a:rPr lang="ru-RU" dirty="0" err="1" smtClean="0"/>
+                        <a:rPr lang="ru-RU" dirty="0" err="1"/>
                         <a:t>език</a:t>
                       </a:r>
                       <a:r>
-                        <a:rPr lang="ru-RU" dirty="0" smtClean="0"/>
+                        <a:rPr lang="ru-RU" dirty="0"/>
                         <a:t> </a:t>
                       </a:r>
                       <a:r>
-                        <a:rPr lang="ru-RU" dirty="0" err="1" smtClean="0"/>
+                        <a:rPr lang="ru-RU" dirty="0" err="1"/>
                         <a:t>въз</a:t>
                       </a:r>
                       <a:r>
-                        <a:rPr lang="ru-RU" dirty="0" smtClean="0"/>
+                        <a:rPr lang="ru-RU" dirty="0"/>
                         <a:t> основа на извлечения контекст.</a:t>
                       </a:r>
                       <a:endParaRPr lang="bg-BG" dirty="0"/>
@@ -8271,7 +8454,7 @@
                     <a:lstStyle/>
                     <a:p>
                       <a:r>
-                        <a:rPr lang="en-US" dirty="0" smtClean="0"/>
+                        <a:rPr lang="en-US" dirty="0"/>
                         <a:t>…</a:t>
                       </a:r>
                       <a:endParaRPr lang="bg-BG" dirty="0"/>
@@ -8285,7 +8468,7 @@
                     <a:lstStyle/>
                     <a:p>
                       <a:r>
-                        <a:rPr lang="en-US" dirty="0" smtClean="0"/>
+                        <a:rPr lang="en-US" dirty="0"/>
                         <a:t>…</a:t>
                       </a:r>
                       <a:endParaRPr lang="bg-BG" dirty="0"/>
@@ -8367,13 +8550,18 @@
   <p:clrMapOvr>
     <a:masterClrMapping/>
   </p:clrMapOvr>
-  <p:timing>
-    <p:tnLst>
-      <p:par>
-        <p:cTn id="1" dur="indefinite" restart="never" nodeType="tmRoot"/>
-      </p:par>
-    </p:tnLst>
-  </p:timing>
+  <mc:AlternateContent xmlns:mc="http://schemas.openxmlformats.org/markup-compatibility/2006">
+    <mc:Choice xmlns:p14="http://schemas.microsoft.com/office/powerpoint/2010/main" Requires="p14">
+      <p:transition spd="slow" p14:dur="1250">
+        <p14:switch dir="r"/>
+      </p:transition>
+    </mc:Choice>
+    <mc:Fallback>
+      <p:transition spd="slow">
+        <p:fade/>
+      </p:transition>
+    </mc:Fallback>
+  </mc:AlternateContent>
 </p:sld>
 </file>
 
@@ -8410,10 +8598,9 @@
           <a:lstStyle/>
           <a:p>
             <a:r>
-              <a:rPr lang="bg-BG" dirty="0" smtClean="0"/>
+              <a:rPr lang="bg-BG" dirty="0"/>
               <a:t>Резултати</a:t>
             </a:r>
-            <a:endParaRPr lang="bg-BG" dirty="0"/>
           </a:p>
         </p:txBody>
       </p:sp>
@@ -8433,92 +8620,84 @@
           <a:lstStyle/>
           <a:p>
             <a:r>
-              <a:rPr lang="en-US" dirty="0" smtClean="0"/>
+              <a:rPr lang="en-US" dirty="0"/>
               <a:t>// TODO – </a:t>
             </a:r>
             <a:r>
-              <a:rPr lang="bg-BG" dirty="0" err="1" smtClean="0"/>
+              <a:rPr lang="bg-BG" dirty="0" err="1"/>
               <a:t>скрийншоти</a:t>
             </a:r>
             <a:r>
-              <a:rPr lang="en-US" dirty="0" smtClean="0"/>
+              <a:rPr lang="en-US" dirty="0"/>
               <a:t>/</a:t>
             </a:r>
             <a:r>
-              <a:rPr lang="bg-BG" dirty="0" smtClean="0"/>
+              <a:rPr lang="bg-BG" dirty="0"/>
               <a:t>копирани примерни </a:t>
             </a:r>
             <a:r>
-              <a:rPr lang="bg-BG" dirty="0" err="1" smtClean="0"/>
+              <a:rPr lang="bg-BG" dirty="0" err="1"/>
               <a:t>промптове</a:t>
             </a:r>
             <a:r>
-              <a:rPr lang="bg-BG" dirty="0" smtClean="0"/>
+              <a:rPr lang="bg-BG" dirty="0"/>
               <a:t> с отговори </a:t>
             </a:r>
             <a:r>
-              <a:rPr lang="en-US" dirty="0" smtClean="0"/>
+              <a:rPr lang="en-US" dirty="0"/>
               <a:t>(</a:t>
             </a:r>
             <a:r>
-              <a:rPr lang="bg-BG" dirty="0" smtClean="0"/>
+              <a:rPr lang="bg-BG" dirty="0"/>
               <a:t>според </a:t>
             </a:r>
             <a:r>
-              <a:rPr lang="en-US" dirty="0" err="1" smtClean="0"/>
+              <a:rPr lang="en-US" dirty="0" err="1"/>
               <a:t>gpt</a:t>
-            </a:r>
-            <a:r>
-              <a:rPr lang="en-US" dirty="0" smtClean="0"/>
-              <a:t> </a:t>
-            </a:r>
-            <a:r>
-              <a:rPr lang="bg-BG" dirty="0" smtClean="0"/>
-              <a:t>може графики за </a:t>
-            </a:r>
-            <a:r>
-              <a:rPr lang="en-US" dirty="0" smtClean="0"/>
-              <a:t>precision, recall</a:t>
-            </a:r>
-            <a:r>
-              <a:rPr lang="bg-BG" dirty="0" smtClean="0"/>
-              <a:t> ама ние като не знаем за всеки въпрос точния отговор</a:t>
             </a:r>
             <a:r>
               <a:rPr lang="en-US" dirty="0"/>
               <a:t> </a:t>
             </a:r>
             <a:r>
-              <a:rPr lang="bg-BG" dirty="0" smtClean="0"/>
+              <a:rPr lang="bg-BG" dirty="0"/>
+              <a:t>може графики за </a:t>
+            </a:r>
+            <a:r>
+              <a:rPr lang="en-US" dirty="0"/>
+              <a:t>precision, recall</a:t>
+            </a:r>
+            <a:r>
+              <a:rPr lang="bg-BG" dirty="0"/>
+              <a:t> ама ние като не знаем за всеки въпрос точния отговор</a:t>
+            </a:r>
+            <a:r>
+              <a:rPr lang="en-US" dirty="0"/>
+              <a:t> </a:t>
+            </a:r>
+            <a:r>
+              <a:rPr lang="bg-BG" dirty="0"/>
               <a:t>става трудно – може би с въпроси от типа </a:t>
             </a:r>
             <a:r>
-              <a:rPr lang="en-US" dirty="0" smtClean="0"/>
+              <a:rPr lang="en-US" dirty="0"/>
               <a:t>“</a:t>
             </a:r>
             <a:r>
-              <a:rPr lang="bg-BG" dirty="0" smtClean="0"/>
+              <a:rPr lang="bg-BG" dirty="0"/>
               <a:t>как се приема </a:t>
             </a:r>
             <a:r>
-              <a:rPr lang="en-US" dirty="0" smtClean="0"/>
+              <a:rPr lang="en-US" dirty="0"/>
               <a:t>[</a:t>
             </a:r>
             <a:r>
-              <a:rPr lang="bg-BG" dirty="0" smtClean="0"/>
+              <a:rPr lang="bg-BG" dirty="0"/>
               <a:t>име на лекарство</a:t>
             </a:r>
             <a:r>
-              <a:rPr lang="en-US" dirty="0" smtClean="0"/>
-              <a:t>]</a:t>
-            </a:r>
-            <a:r>
               <a:rPr lang="en-US" dirty="0"/>
-              <a:t>?</a:t>
-            </a:r>
-            <a:r>
-              <a:rPr lang="en-US" dirty="0" smtClean="0"/>
-              <a:t>”)</a:t>
+              <a:t>]?”)</a:t>
             </a:r>
             <a:endParaRPr lang="bg-BG" dirty="0"/>
           </a:p>
@@ -8534,13 +8713,18 @@
   <p:clrMapOvr>
     <a:masterClrMapping/>
   </p:clrMapOvr>
-  <p:timing>
-    <p:tnLst>
-      <p:par>
-        <p:cTn id="1" dur="indefinite" restart="never" nodeType="tmRoot"/>
-      </p:par>
-    </p:tnLst>
-  </p:timing>
+  <mc:AlternateContent xmlns:mc="http://schemas.openxmlformats.org/markup-compatibility/2006">
+    <mc:Choice xmlns:p15="http://schemas.microsoft.com/office/powerpoint/2012/main" Requires="p15">
+      <p:transition xmlns:p14="http://schemas.microsoft.com/office/powerpoint/2010/main" spd="slow" p14:dur="2000">
+        <p15:prstTrans prst="drape"/>
+      </p:transition>
+    </mc:Choice>
+    <mc:Fallback>
+      <p:transition spd="slow">
+        <p:fade/>
+      </p:transition>
+    </mc:Fallback>
+  </mc:AlternateContent>
 </p:sld>
 </file>
 
@@ -8577,10 +8761,9 @@
           <a:lstStyle/>
           <a:p>
             <a:r>
-              <a:rPr lang="bg-BG" dirty="0" smtClean="0"/>
+              <a:rPr lang="bg-BG" dirty="0"/>
               <a:t>Сравнение на подходи</a:t>
             </a:r>
-            <a:endParaRPr lang="bg-BG" dirty="0"/>
           </a:p>
         </p:txBody>
       </p:sp>
@@ -8600,39 +8783,39 @@
           <a:lstStyle/>
           <a:p>
             <a:r>
-              <a:rPr lang="en-US" dirty="0" smtClean="0"/>
+              <a:rPr lang="en-US" dirty="0"/>
               <a:t>// TODO: </a:t>
             </a:r>
             <a:r>
-              <a:rPr lang="bg-BG" dirty="0" smtClean="0"/>
+              <a:rPr lang="bg-BG" dirty="0"/>
               <a:t>Според </a:t>
             </a:r>
             <a:r>
-              <a:rPr lang="en-US" dirty="0" smtClean="0"/>
+              <a:rPr lang="en-US" dirty="0"/>
               <a:t>GPT </a:t>
             </a:r>
             <a:r>
-              <a:rPr lang="bg-BG" dirty="0" smtClean="0"/>
+              <a:rPr lang="bg-BG" dirty="0"/>
               <a:t>тук да кажем кога е по-добър резултата и кога по-лош </a:t>
             </a:r>
             <a:r>
-              <a:rPr lang="en-US" dirty="0" smtClean="0"/>
+              <a:rPr lang="en-US" dirty="0"/>
               <a:t>(</a:t>
             </a:r>
             <a:r>
-              <a:rPr lang="bg-BG" dirty="0" smtClean="0"/>
+              <a:rPr lang="bg-BG" dirty="0"/>
               <a:t>например ако променим цепенето на данните</a:t>
             </a:r>
             <a:r>
-              <a:rPr lang="en-US" dirty="0" smtClean="0"/>
+              <a:rPr lang="en-US" dirty="0"/>
               <a:t>, </a:t>
             </a:r>
             <a:r>
-              <a:rPr lang="bg-BG" dirty="0" smtClean="0"/>
+              <a:rPr lang="bg-BG" dirty="0"/>
               <a:t>или ако опитваме с различни модели</a:t>
             </a:r>
             <a:r>
-              <a:rPr lang="en-US" dirty="0" smtClean="0"/>
+              <a:rPr lang="en-US" dirty="0"/>
               <a:t>)</a:t>
             </a:r>
             <a:endParaRPr lang="bg-BG" dirty="0"/>
@@ -8649,13 +8832,6 @@
   <p:clrMapOvr>
     <a:masterClrMapping/>
   </p:clrMapOvr>
-  <p:timing>
-    <p:tnLst>
-      <p:par>
-        <p:cTn id="1" dur="indefinite" restart="never" nodeType="tmRoot"/>
-      </p:par>
-    </p:tnLst>
-  </p:timing>
 </p:sld>
 </file>
 
@@ -8692,10 +8868,9 @@
           <a:lstStyle/>
           <a:p>
             <a:r>
-              <a:rPr lang="bg-BG" dirty="0" smtClean="0"/>
+              <a:rPr lang="bg-BG" dirty="0"/>
               <a:t>Недостатъци</a:t>
             </a:r>
-            <a:endParaRPr lang="bg-BG" dirty="0"/>
           </a:p>
         </p:txBody>
       </p:sp>
@@ -8724,16 +8899,12 @@
               <a:buChar char="Ø"/>
             </a:pPr>
             <a:r>
-              <a:rPr lang="ru-RU" dirty="0" err="1" smtClean="0"/>
+              <a:rPr lang="ru-RU" dirty="0" err="1"/>
               <a:t>Някои</a:t>
             </a:r>
             <a:r>
-              <a:rPr lang="ru-RU" dirty="0" smtClean="0"/>
-              <a:t> </a:t>
-            </a:r>
-            <a:r>
               <a:rPr lang="ru-RU" dirty="0"/>
-              <a:t>PDF </a:t>
+              <a:t> PDF </a:t>
             </a:r>
             <a:r>
               <a:rPr lang="ru-RU" dirty="0" err="1"/>
@@ -8766,16 +8937,12 @@
               <a:buChar char="Ø"/>
             </a:pPr>
             <a:r>
-              <a:rPr lang="ru-RU" dirty="0" err="1" smtClean="0"/>
+              <a:rPr lang="ru-RU" dirty="0" err="1"/>
               <a:t>Системата</a:t>
             </a:r>
             <a:r>
-              <a:rPr lang="ru-RU" dirty="0" smtClean="0"/>
-              <a:t> </a:t>
-            </a:r>
-            <a:r>
               <a:rPr lang="ru-RU" dirty="0"/>
-              <a:t>не </a:t>
+              <a:t> не </a:t>
             </a:r>
             <a:r>
               <a:rPr lang="ru-RU" dirty="0" err="1"/>
@@ -8828,13 +8995,6 @@
   <p:clrMapOvr>
     <a:masterClrMapping/>
   </p:clrMapOvr>
-  <p:timing>
-    <p:tnLst>
-      <p:par>
-        <p:cTn id="1" dur="indefinite" restart="never" nodeType="tmRoot"/>
-      </p:par>
-    </p:tnLst>
-  </p:timing>
 </p:sld>
 </file>
 
@@ -8871,11 +9031,11 @@
           <a:lstStyle/>
           <a:p>
             <a:r>
-              <a:rPr lang="bg-BG" dirty="0" smtClean="0"/>
+              <a:rPr lang="bg-BG" dirty="0"/>
               <a:t>Подобрения </a:t>
             </a:r>
             <a:r>
-              <a:rPr lang="en-US" dirty="0" smtClean="0"/>
+              <a:rPr lang="en-US" dirty="0"/>
               <a:t>// TODO – maybe change title</a:t>
             </a:r>
             <a:endParaRPr lang="bg-BG" dirty="0"/>
@@ -8902,43 +9062,43 @@
               <a:buChar char="Ø"/>
             </a:pPr>
             <a:r>
-              <a:rPr lang="bg-BG" dirty="0" smtClean="0"/>
+              <a:rPr lang="bg-BG" dirty="0"/>
               <a:t>Използване на модел</a:t>
             </a:r>
             <a:r>
-              <a:rPr lang="en-US" dirty="0" smtClean="0"/>
+              <a:rPr lang="en-US" dirty="0"/>
               <a:t> (TODO: </a:t>
             </a:r>
             <a:r>
-              <a:rPr lang="bg-BG" dirty="0" smtClean="0"/>
+              <a:rPr lang="bg-BG" dirty="0"/>
               <a:t>Сами – подробности </a:t>
             </a:r>
             <a:r>
-              <a:rPr lang="en-US" dirty="0" err="1" smtClean="0"/>
+              <a:rPr lang="en-US" dirty="0" err="1"/>
               <a:t>pls</a:t>
             </a:r>
             <a:r>
-              <a:rPr lang="en-US" dirty="0" smtClean="0"/>
+              <a:rPr lang="en-US" dirty="0"/>
               <a:t>)</a:t>
             </a:r>
             <a:r>
-              <a:rPr lang="bg-BG" dirty="0" smtClean="0"/>
+              <a:rPr lang="bg-BG" dirty="0"/>
               <a:t> за изчистване на данните </a:t>
             </a:r>
             <a:r>
-              <a:rPr lang="en-US" dirty="0" smtClean="0"/>
+              <a:rPr lang="en-US" dirty="0"/>
               <a:t>(</a:t>
             </a:r>
             <a:r>
-              <a:rPr lang="bg-BG" dirty="0" smtClean="0"/>
+              <a:rPr lang="bg-BG" dirty="0"/>
               <a:t>скъпо</a:t>
             </a:r>
             <a:r>
-              <a:rPr lang="en-US" dirty="0" smtClean="0"/>
+              <a:rPr lang="en-US" dirty="0"/>
               <a:t>)</a:t>
             </a:r>
             <a:r>
-              <a:rPr lang="bg-BG" dirty="0" smtClean="0"/>
+              <a:rPr lang="bg-BG" dirty="0"/>
               <a:t>.</a:t>
             </a:r>
           </a:p>
@@ -8948,18 +9108,17 @@
               <a:buChar char="Ø"/>
             </a:pPr>
             <a:r>
-              <a:rPr lang="bg-BG" dirty="0" smtClean="0"/>
+              <a:rPr lang="bg-BG" dirty="0"/>
               <a:t>Използване на генеративни модели</a:t>
             </a:r>
             <a:r>
-              <a:rPr lang="en-US" dirty="0" smtClean="0"/>
+              <a:rPr lang="en-US" dirty="0"/>
               <a:t>, </a:t>
             </a:r>
             <a:r>
-              <a:rPr lang="bg-BG" dirty="0" smtClean="0"/>
+              <a:rPr lang="bg-BG" dirty="0"/>
               <a:t>които са по-добре тренирани върху български език.</a:t>
             </a:r>
-            <a:endParaRPr lang="bg-BG" dirty="0"/>
           </a:p>
         </p:txBody>
       </p:sp>
@@ -8973,13 +9132,6 @@
   <p:clrMapOvr>
     <a:masterClrMapping/>
   </p:clrMapOvr>
-  <p:timing>
-    <p:tnLst>
-      <p:par>
-        <p:cTn id="1" dur="indefinite" restart="never" nodeType="tmRoot"/>
-      </p:par>
-    </p:tnLst>
-  </p:timing>
 </p:sld>
 </file>
 
@@ -9016,10 +9168,9 @@
           <a:lstStyle/>
           <a:p>
             <a:r>
-              <a:rPr lang="bg-BG" dirty="0" smtClean="0"/>
+              <a:rPr lang="bg-BG" dirty="0"/>
               <a:t>Демонстрация</a:t>
             </a:r>
-            <a:endParaRPr lang="bg-BG" dirty="0"/>
           </a:p>
         </p:txBody>
       </p:sp>
@@ -9069,10 +9220,9 @@
           <a:lstStyle/>
           <a:p>
             <a:r>
-              <a:rPr lang="bg-BG" dirty="0" smtClean="0"/>
+              <a:rPr lang="bg-BG" dirty="0"/>
               <a:t>Благодарим за вниманието!</a:t>
             </a:r>
-            <a:endParaRPr lang="bg-BG" dirty="0"/>
           </a:p>
         </p:txBody>
       </p:sp>
@@ -9086,13 +9236,18 @@
   <p:clrMapOvr>
     <a:masterClrMapping/>
   </p:clrMapOvr>
-  <p:timing>
-    <p:tnLst>
-      <p:par>
-        <p:cTn id="1" dur="indefinite" restart="never" nodeType="tmRoot"/>
-      </p:par>
-    </p:tnLst>
-  </p:timing>
+  <mc:AlternateContent xmlns:mc="http://schemas.openxmlformats.org/markup-compatibility/2006">
+    <mc:Choice xmlns:p15="http://schemas.microsoft.com/office/powerpoint/2012/main" Requires="p15">
+      <p:transition xmlns:p14="http://schemas.microsoft.com/office/powerpoint/2010/main" spd="slow" p14:dur="4000">
+        <p15:prstTrans prst="curtains"/>
+      </p:transition>
+    </mc:Choice>
+    <mc:Fallback>
+      <p:transition spd="slow">
+        <p:fade/>
+      </p:transition>
+    </mc:Fallback>
+  </mc:AlternateContent>
 </p:sld>
 </file>
 
@@ -9129,10 +9284,9 @@
           <a:lstStyle/>
           <a:p>
             <a:r>
-              <a:rPr lang="bg-BG" dirty="0" smtClean="0"/>
+              <a:rPr lang="bg-BG" dirty="0"/>
               <a:t>Задача и мотивация</a:t>
             </a:r>
-            <a:endParaRPr lang="bg-BG" dirty="0"/>
           </a:p>
         </p:txBody>
       </p:sp>
@@ -9454,13 +9608,6 @@
   <p:clrMapOvr>
     <a:masterClrMapping/>
   </p:clrMapOvr>
-  <p:timing>
-    <p:tnLst>
-      <p:par>
-        <p:cTn id="1" dur="indefinite" restart="never" nodeType="tmRoot"/>
-      </p:par>
-    </p:tnLst>
-  </p:timing>
 </p:sld>
 </file>
 
@@ -9497,10 +9644,9 @@
           <a:lstStyle/>
           <a:p>
             <a:r>
-              <a:rPr lang="bg-BG" dirty="0" smtClean="0"/>
+              <a:rPr lang="bg-BG" dirty="0"/>
               <a:t>Предизвикателства</a:t>
             </a:r>
-            <a:endParaRPr lang="bg-BG" dirty="0"/>
           </a:p>
         </p:txBody>
       </p:sp>
@@ -9524,7 +9670,7 @@
               <a:buChar char="Ø"/>
             </a:pPr>
             <a:r>
-              <a:rPr lang="ru-RU" dirty="0" smtClean="0"/>
+              <a:rPr lang="ru-RU" dirty="0"/>
               <a:t>PDF </a:t>
             </a:r>
             <a:r>
@@ -9560,19 +9706,19 @@
               <a:buChar char="Ø"/>
             </a:pPr>
             <a:r>
-              <a:rPr lang="ru-RU" dirty="0" err="1" smtClean="0"/>
+              <a:rPr lang="ru-RU" dirty="0" err="1"/>
               <a:t>Дълги</a:t>
             </a:r>
             <a:r>
-              <a:rPr lang="ru-RU" dirty="0" smtClean="0"/>
+              <a:rPr lang="ru-RU" dirty="0"/>
               <a:t> </a:t>
             </a:r>
             <a:r>
-              <a:rPr lang="ru-RU" dirty="0" err="1" smtClean="0"/>
+              <a:rPr lang="ru-RU" dirty="0" err="1"/>
               <a:t>документи</a:t>
             </a:r>
             <a:r>
-              <a:rPr lang="ru-RU" dirty="0" smtClean="0"/>
+              <a:rPr lang="ru-RU" dirty="0"/>
               <a:t>. </a:t>
             </a:r>
           </a:p>
@@ -9582,16 +9728,12 @@
               <a:buChar char="Ø"/>
             </a:pPr>
             <a:r>
-              <a:rPr lang="ru-RU" dirty="0" err="1" smtClean="0"/>
+              <a:rPr lang="ru-RU" dirty="0" err="1"/>
               <a:t>Медицинска</a:t>
             </a:r>
             <a:r>
-              <a:rPr lang="ru-RU" dirty="0" smtClean="0"/>
-              <a:t> </a:t>
-            </a:r>
-            <a:r>
               <a:rPr lang="ru-RU" dirty="0"/>
-              <a:t>терминология. </a:t>
+              <a:t> терминология. </a:t>
             </a:r>
           </a:p>
           <a:p>
@@ -9628,13 +9770,9 @@
   <p:clrMapOvr>
     <a:masterClrMapping/>
   </p:clrMapOvr>
-  <p:timing>
-    <p:tnLst>
-      <p:par>
-        <p:cTn id="1" dur="indefinite" restart="never" nodeType="tmRoot"/>
-      </p:par>
-    </p:tnLst>
-  </p:timing>
+  <p:transition spd="slow">
+    <p:cover/>
+  </p:transition>
 </p:sld>
 </file>
 
@@ -9671,10 +9809,9 @@
           <a:lstStyle/>
           <a:p>
             <a:r>
-              <a:rPr lang="bg-BG" dirty="0" smtClean="0"/>
+              <a:rPr lang="bg-BG" dirty="0"/>
               <a:t>Предизвикателства</a:t>
             </a:r>
-            <a:endParaRPr lang="bg-BG" dirty="0"/>
           </a:p>
         </p:txBody>
       </p:sp>
@@ -9699,14 +9836,13 @@
           <a:lstStyle/>
           <a:p>
             <a:r>
-              <a:rPr lang="en-US" dirty="0" smtClean="0"/>
+              <a:rPr lang="en-US" dirty="0"/>
               <a:t>PDF </a:t>
             </a:r>
             <a:r>
-              <a:rPr lang="bg-BG" dirty="0" smtClean="0"/>
+              <a:rPr lang="bg-BG" dirty="0"/>
               <a:t>на листовка</a:t>
             </a:r>
-            <a:endParaRPr lang="bg-BG" dirty="0"/>
           </a:p>
         </p:txBody>
       </p:sp>
@@ -9760,10 +9896,9 @@
           <a:lstStyle/>
           <a:p>
             <a:r>
-              <a:rPr lang="bg-BG" dirty="0" smtClean="0"/>
+              <a:rPr lang="bg-BG" dirty="0"/>
               <a:t>След извличане</a:t>
             </a:r>
-            <a:endParaRPr lang="bg-BG" dirty="0"/>
           </a:p>
         </p:txBody>
       </p:sp>
@@ -9928,13 +10063,9 @@
   <p:clrMapOvr>
     <a:masterClrMapping/>
   </p:clrMapOvr>
-  <p:timing>
-    <p:tnLst>
-      <p:par>
-        <p:cTn id="1" dur="indefinite" restart="never" nodeType="tmRoot"/>
-      </p:par>
-    </p:tnLst>
-  </p:timing>
+  <p:transition spd="slow">
+    <p:wipe dir="u"/>
+  </p:transition>
 </p:sld>
 </file>
 
@@ -9971,10 +10102,9 @@
           <a:lstStyle/>
           <a:p>
             <a:r>
-              <a:rPr lang="bg-BG" dirty="0" smtClean="0"/>
+              <a:rPr lang="bg-BG" dirty="0"/>
               <a:t>Общ преглед на решението</a:t>
             </a:r>
-            <a:endParaRPr lang="bg-BG" dirty="0"/>
           </a:p>
         </p:txBody>
       </p:sp>
@@ -9994,33 +10124,21 @@
           <a:lstStyle/>
           <a:p>
             <a:r>
-              <a:rPr lang="bg-BG" dirty="0" smtClean="0"/>
-              <a:t>Подготовка </a:t>
-            </a:r>
-            <a:r>
               <a:rPr lang="bg-BG" dirty="0"/>
-              <a:t>на </a:t>
-            </a:r>
-            <a:r>
-              <a:rPr lang="bg-BG" dirty="0" smtClean="0"/>
-              <a:t>данните</a:t>
-            </a:r>
-            <a:endParaRPr lang="en-US" dirty="0" smtClean="0"/>
+              <a:t>Подготовка на данните</a:t>
+            </a:r>
+            <a:endParaRPr lang="en-US" dirty="0"/>
           </a:p>
           <a:p>
             <a:r>
               <a:rPr lang="bg-BG" dirty="0"/>
-              <a:t>Сегментиране по </a:t>
-            </a:r>
-            <a:r>
-              <a:rPr lang="bg-BG" dirty="0" smtClean="0"/>
-              <a:t>секции</a:t>
-            </a:r>
-            <a:r>
-              <a:rPr lang="en-US" dirty="0" smtClean="0"/>
+              <a:t>Сегментиране по секции</a:t>
+            </a:r>
+            <a:r>
+              <a:rPr lang="en-US" dirty="0"/>
               <a:t> </a:t>
             </a:r>
-            <a:endParaRPr lang="bg-BG" dirty="0" smtClean="0"/>
+            <a:endParaRPr lang="bg-BG" dirty="0"/>
           </a:p>
           <a:p>
             <a:r>
@@ -10028,26 +10146,25 @@
               <a:t>Chunking </a:t>
             </a:r>
             <a:r>
-              <a:rPr lang="bg-BG" dirty="0" smtClean="0"/>
+              <a:rPr lang="bg-BG" dirty="0"/>
               <a:t>стратегия</a:t>
             </a:r>
           </a:p>
           <a:p>
             <a:r>
-              <a:rPr lang="en-US" dirty="0" err="1" smtClean="0"/>
+              <a:rPr lang="en-US" dirty="0" err="1"/>
               <a:t>Embeddings</a:t>
             </a:r>
-            <a:endParaRPr lang="bg-BG" dirty="0" smtClean="0"/>
+            <a:endParaRPr lang="bg-BG" dirty="0"/>
           </a:p>
           <a:p>
             <a:r>
               <a:rPr lang="bg-BG" dirty="0"/>
               <a:t>Извличане и генериране</a:t>
             </a:r>
-            <a:endParaRPr lang="bg-BG" dirty="0" smtClean="0"/>
-          </a:p>
-          <a:p>
-            <a:endParaRPr lang="en-US" dirty="0" smtClean="0"/>
+          </a:p>
+          <a:p>
+            <a:endParaRPr lang="en-US" dirty="0"/>
           </a:p>
           <a:p>
             <a:endParaRPr lang="bg-BG" dirty="0"/>
@@ -10064,13 +10181,9 @@
   <p:clrMapOvr>
     <a:masterClrMapping/>
   </p:clrMapOvr>
-  <p:timing>
-    <p:tnLst>
-      <p:par>
-        <p:cTn id="1" dur="indefinite" restart="never" nodeType="tmRoot"/>
-      </p:par>
-    </p:tnLst>
-  </p:timing>
+  <p:transition spd="med">
+    <p:pull/>
+  </p:transition>
 </p:sld>
 </file>
 
@@ -10107,10 +10220,9 @@
           <a:lstStyle/>
           <a:p>
             <a:r>
-              <a:rPr lang="bg-BG" dirty="0" smtClean="0"/>
+              <a:rPr lang="bg-BG" dirty="0"/>
               <a:t>Подготовка на данните</a:t>
             </a:r>
-            <a:endParaRPr lang="bg-BG" dirty="0"/>
           </a:p>
         </p:txBody>
       </p:sp>
@@ -10136,11 +10248,11 @@
               <a:buChar char="Ø"/>
             </a:pPr>
             <a:r>
-              <a:rPr lang="bg-BG" dirty="0" smtClean="0"/>
+              <a:rPr lang="bg-BG" dirty="0"/>
               <a:t>Източник на данни – </a:t>
             </a:r>
             <a:r>
-              <a:rPr lang="bg-BG" dirty="0" smtClean="0">
+              <a:rPr lang="bg-BG" dirty="0">
                 <a:hlinkClick r:id="rId2"/>
               </a:rPr>
               <a:t>листовки за пациента от ИАЛ</a:t>
@@ -10155,11 +10267,11 @@
               <a:buChar char="o"/>
             </a:pPr>
             <a:r>
-              <a:rPr lang="bg-BG" dirty="0" smtClean="0"/>
+              <a:rPr lang="bg-BG" dirty="0"/>
               <a:t>Формат </a:t>
             </a:r>
             <a:r>
-              <a:rPr lang="en-US" dirty="0" smtClean="0"/>
+              <a:rPr lang="en-US" dirty="0"/>
               <a:t>PDF</a:t>
             </a:r>
           </a:p>
@@ -10169,7 +10281,7 @@
               <a:buChar char="Ø"/>
             </a:pPr>
             <a:r>
-              <a:rPr lang="ru-RU" dirty="0" smtClean="0"/>
+              <a:rPr lang="ru-RU" dirty="0"/>
               <a:t>Обработка:</a:t>
             </a:r>
           </a:p>
@@ -10179,16 +10291,12 @@
               <a:buChar char="o"/>
             </a:pPr>
             <a:r>
-              <a:rPr lang="ru-RU" dirty="0" err="1" smtClean="0"/>
+              <a:rPr lang="ru-RU" dirty="0" err="1"/>
               <a:t>Конвертиране</a:t>
             </a:r>
             <a:r>
-              <a:rPr lang="ru-RU" dirty="0" smtClean="0"/>
-              <a:t> </a:t>
-            </a:r>
-            <a:r>
               <a:rPr lang="ru-RU" dirty="0"/>
-              <a:t>в текст </a:t>
+              <a:t> в текст </a:t>
             </a:r>
           </a:p>
           <a:p>
@@ -10221,15 +10329,15 @@
               <a:buChar char="Ø"/>
             </a:pPr>
             <a:r>
-              <a:rPr lang="ru-RU" dirty="0" err="1" smtClean="0"/>
+              <a:rPr lang="ru-RU" dirty="0" err="1"/>
               <a:t>Брой</a:t>
             </a:r>
             <a:r>
-              <a:rPr lang="ru-RU" dirty="0" smtClean="0"/>
+              <a:rPr lang="ru-RU" dirty="0"/>
               <a:t>:</a:t>
             </a:r>
             <a:r>
-              <a:rPr lang="en-US" dirty="0" smtClean="0"/>
+              <a:rPr lang="en-US" dirty="0"/>
               <a:t> </a:t>
             </a:r>
           </a:p>
@@ -10239,11 +10347,11 @@
               <a:buChar char="o"/>
             </a:pPr>
             <a:r>
-              <a:rPr lang="en-US" dirty="0" smtClean="0"/>
+              <a:rPr lang="en-US" dirty="0"/>
               <a:t>1438</a:t>
             </a:r>
             <a:r>
-              <a:rPr lang="ru-RU" dirty="0" smtClean="0"/>
+              <a:rPr lang="ru-RU" dirty="0"/>
               <a:t> листовки </a:t>
             </a:r>
           </a:p>
@@ -10253,16 +10361,12 @@
               <a:buChar char="o"/>
             </a:pPr>
             <a:r>
-              <a:rPr lang="en-US" dirty="0" smtClean="0"/>
+              <a:rPr lang="en-US" dirty="0"/>
               <a:t>42</a:t>
             </a:r>
             <a:r>
-              <a:rPr lang="ru-RU" dirty="0" smtClean="0"/>
-              <a:t> </a:t>
-            </a:r>
-            <a:r>
               <a:rPr lang="ru-RU" dirty="0"/>
-              <a:t>MB текст</a:t>
+              <a:t> MB текст</a:t>
             </a:r>
           </a:p>
           <a:p>
@@ -10270,7 +10374,7 @@
               <a:buFont typeface="Wingdings" panose="05000000000000000000" pitchFamily="2" charset="2"/>
               <a:buChar char="Ø"/>
             </a:pPr>
-            <a:endParaRPr lang="bg-BG" dirty="0" smtClean="0"/>
+            <a:endParaRPr lang="bg-BG" dirty="0"/>
           </a:p>
         </p:txBody>
       </p:sp>
@@ -10284,13 +10388,18 @@
   <p:clrMapOvr>
     <a:masterClrMapping/>
   </p:clrMapOvr>
-  <p:timing>
-    <p:tnLst>
-      <p:par>
-        <p:cTn id="1" dur="indefinite" restart="never" nodeType="tmRoot"/>
-      </p:par>
-    </p:tnLst>
-  </p:timing>
+  <mc:AlternateContent xmlns:mc="http://schemas.openxmlformats.org/markup-compatibility/2006">
+    <mc:Choice xmlns:p159="http://schemas.microsoft.com/office/powerpoint/2015/09/main" Requires="p159">
+      <p:transition xmlns:p14="http://schemas.microsoft.com/office/powerpoint/2010/main" spd="slow" p14:dur="2000">
+        <p159:morph option="byObject"/>
+      </p:transition>
+    </mc:Choice>
+    <mc:Fallback>
+      <p:transition spd="slow">
+        <p:fade/>
+      </p:transition>
+    </mc:Fallback>
+  </mc:AlternateContent>
 </p:sld>
 </file>
 
@@ -10327,10 +10436,9 @@
           <a:lstStyle/>
           <a:p>
             <a:r>
-              <a:rPr lang="bg-BG" dirty="0" smtClean="0"/>
+              <a:rPr lang="bg-BG" dirty="0"/>
               <a:t>Сегментиране по секции</a:t>
             </a:r>
-            <a:endParaRPr lang="bg-BG" dirty="0"/>
           </a:p>
         </p:txBody>
       </p:sp>
@@ -10359,41 +10467,41 @@
               <a:buChar char="Ø"/>
             </a:pPr>
             <a:r>
-              <a:rPr lang="ru-RU" dirty="0" smtClean="0"/>
+              <a:rPr lang="ru-RU" dirty="0"/>
               <a:t>Известен формат</a:t>
             </a:r>
             <a:r>
-              <a:rPr lang="en-US" dirty="0" smtClean="0"/>
+              <a:rPr lang="en-US" dirty="0"/>
               <a:t> </a:t>
             </a:r>
             <a:r>
-              <a:rPr lang="bg-BG" dirty="0" smtClean="0"/>
+              <a:rPr lang="bg-BG" dirty="0"/>
               <a:t>на всяка листовка</a:t>
             </a:r>
             <a:r>
-              <a:rPr lang="en-US" dirty="0" smtClean="0"/>
+              <a:rPr lang="en-US" dirty="0"/>
               <a:t>:</a:t>
             </a:r>
-            <a:endParaRPr lang="ru-RU" dirty="0" smtClean="0"/>
+            <a:endParaRPr lang="ru-RU" dirty="0"/>
           </a:p>
           <a:p>
             <a:pPr marL="0" indent="0">
               <a:buNone/>
             </a:pPr>
             <a:r>
-              <a:rPr lang="ru-RU" dirty="0" smtClean="0"/>
+              <a:rPr lang="ru-RU" dirty="0"/>
               <a:t>1</a:t>
             </a:r>
             <a:r>
-              <a:rPr lang="en-US" dirty="0" smtClean="0"/>
+              <a:rPr lang="en-US" dirty="0"/>
               <a:t>. </a:t>
             </a:r>
             <a:r>
-              <a:rPr lang="ru-RU" dirty="0" err="1" smtClean="0"/>
+              <a:rPr lang="ru-RU" dirty="0" err="1"/>
               <a:t>Какво</a:t>
             </a:r>
             <a:r>
-              <a:rPr lang="ru-RU" dirty="0" smtClean="0"/>
+              <a:rPr lang="ru-RU" dirty="0"/>
               <a:t> </a:t>
             </a:r>
             <a:r>
@@ -10477,7 +10585,7 @@
               <a:t>съхранявате</a:t>
             </a:r>
             <a:r>
-              <a:rPr lang="ru-RU" dirty="0" smtClean="0"/>
+              <a:rPr lang="ru-RU" dirty="0"/>
               <a:t>...</a:t>
             </a:r>
           </a:p>
@@ -10485,7 +10593,7 @@
             <a:pPr marL="0" indent="0">
               <a:buNone/>
             </a:pPr>
-            <a:endParaRPr lang="ru-RU" dirty="0" smtClean="0"/>
+            <a:endParaRPr lang="ru-RU" dirty="0"/>
           </a:p>
           <a:p>
             <a:pPr>
@@ -10493,11 +10601,11 @@
               <a:buChar char="o"/>
             </a:pPr>
             <a:r>
-              <a:rPr lang="ru-RU" dirty="0" err="1" smtClean="0"/>
+              <a:rPr lang="ru-RU" dirty="0" err="1"/>
               <a:t>Използвани</a:t>
             </a:r>
             <a:r>
-              <a:rPr lang="ru-RU" dirty="0" smtClean="0"/>
+              <a:rPr lang="ru-RU" dirty="0"/>
               <a:t> </a:t>
             </a:r>
             <a:r>
@@ -10517,18 +10625,18 @@
               <a:t> заглавия на </a:t>
             </a:r>
             <a:r>
-              <a:rPr lang="bg-BG" dirty="0" smtClean="0"/>
+              <a:rPr lang="bg-BG" dirty="0"/>
               <a:t>секции на </a:t>
             </a:r>
             <a:r>
-              <a:rPr lang="ru-RU" dirty="0" err="1" smtClean="0"/>
+              <a:rPr lang="ru-RU" dirty="0" err="1"/>
               <a:t>листовките</a:t>
             </a:r>
             <a:r>
-              <a:rPr lang="ru-RU" dirty="0" smtClean="0"/>
+              <a:rPr lang="ru-RU" dirty="0"/>
               <a:t>.</a:t>
             </a:r>
-            <a:endParaRPr lang="bg-BG" dirty="0" smtClean="0"/>
+            <a:endParaRPr lang="bg-BG" dirty="0"/>
           </a:p>
           <a:p>
             <a:pPr>
@@ -10572,10 +10680,9 @@
               <a:t>извличането</a:t>
             </a:r>
             <a:r>
-              <a:rPr lang="ru-RU" dirty="0" smtClean="0"/>
+              <a:rPr lang="ru-RU" dirty="0"/>
               <a:t>.</a:t>
             </a:r>
-            <a:endParaRPr lang="ru-RU" dirty="0"/>
           </a:p>
           <a:p>
             <a:pPr>
@@ -10595,7 +10702,7 @@
               <a:t>индексът</a:t>
             </a:r>
             <a:r>
-              <a:rPr lang="en-US" dirty="0" smtClean="0"/>
+              <a:rPr lang="en-US" dirty="0"/>
               <a:t>).</a:t>
             </a:r>
             <a:endParaRPr lang="bg-BG" dirty="0"/>
@@ -10612,13 +10719,18 @@
   <p:clrMapOvr>
     <a:masterClrMapping/>
   </p:clrMapOvr>
-  <p:timing>
-    <p:tnLst>
-      <p:par>
-        <p:cTn id="1" dur="indefinite" restart="never" nodeType="tmRoot"/>
-      </p:par>
-    </p:tnLst>
-  </p:timing>
+  <mc:AlternateContent xmlns:mc="http://schemas.openxmlformats.org/markup-compatibility/2006">
+    <mc:Choice xmlns:p15="http://schemas.microsoft.com/office/powerpoint/2012/main" Requires="p15">
+      <p:transition xmlns:p14="http://schemas.microsoft.com/office/powerpoint/2010/main" spd="slow" p14:dur="1250">
+        <p15:prstTrans prst="pageCurlDouble"/>
+      </p:transition>
+    </mc:Choice>
+    <mc:Fallback>
+      <p:transition spd="slow">
+        <p:fade/>
+      </p:transition>
+    </mc:Fallback>
+  </mc:AlternateContent>
 </p:sld>
 </file>
 
@@ -10660,14 +10772,13 @@
           <a:lstStyle/>
           <a:p>
             <a:r>
-              <a:rPr lang="en-US" dirty="0" smtClean="0"/>
+              <a:rPr lang="en-US" dirty="0"/>
               <a:t>Chunking </a:t>
             </a:r>
             <a:r>
-              <a:rPr lang="bg-BG" dirty="0" smtClean="0"/>
+              <a:rPr lang="bg-BG" dirty="0"/>
               <a:t>стратегия</a:t>
             </a:r>
-            <a:endParaRPr lang="bg-BG" dirty="0"/>
           </a:p>
         </p:txBody>
       </p:sp>
@@ -10697,24 +10808,23 @@
               <a:buNone/>
             </a:pPr>
             <a:r>
-              <a:rPr lang="ru-RU" dirty="0" smtClean="0"/>
+              <a:rPr lang="ru-RU" dirty="0"/>
               <a:t>Примерен </a:t>
             </a:r>
             <a:r>
-              <a:rPr lang="en-US" dirty="0" smtClean="0"/>
+              <a:rPr lang="en-US" dirty="0"/>
               <a:t>chunk:</a:t>
             </a:r>
-            <a:endParaRPr lang="ru-RU" dirty="0" smtClean="0"/>
+            <a:endParaRPr lang="ru-RU" dirty="0"/>
           </a:p>
           <a:p>
             <a:pPr marL="0" indent="0">
               <a:buNone/>
             </a:pPr>
             <a:r>
-              <a:rPr lang="ru-RU" dirty="0" smtClean="0"/>
+              <a:rPr lang="ru-RU" dirty="0"/>
               <a:t>{</a:t>
             </a:r>
-            <a:endParaRPr lang="ru-RU" dirty="0"/>
           </a:p>
           <a:p>
             <a:pPr marL="0" indent="0">
@@ -10813,12 +10923,8 @@
               <a:t>9</a:t>
             </a:r>
             <a:r>
-              <a:rPr lang="ru-RU" dirty="0" smtClean="0"/>
-              <a:t>23</a:t>
-            </a:r>
-            <a:r>
               <a:rPr lang="ru-RU" dirty="0"/>
-              <a:t>,</a:t>
+              <a:t>23,</a:t>
             </a:r>
           </a:p>
           <a:p>
@@ -10838,88 +10944,84 @@
               <a:t>": "</a:t>
             </a:r>
             <a:r>
-              <a:rPr lang="ru-RU" dirty="0" err="1" smtClean="0"/>
+              <a:rPr lang="ru-RU" dirty="0" err="1"/>
               <a:t>Както</a:t>
             </a:r>
             <a:r>
-              <a:rPr lang="ru-RU" dirty="0" smtClean="0"/>
+              <a:rPr lang="ru-RU" dirty="0"/>
               <a:t> </a:t>
             </a:r>
             <a:r>
-              <a:rPr lang="ru-RU" dirty="0" err="1" smtClean="0"/>
+              <a:rPr lang="ru-RU" dirty="0" err="1"/>
               <a:t>всички</a:t>
             </a:r>
             <a:r>
-              <a:rPr lang="ru-RU" dirty="0" smtClean="0"/>
+              <a:rPr lang="ru-RU" dirty="0"/>
               <a:t> лекарства, </a:t>
             </a:r>
             <a:r>
-              <a:rPr lang="ru-RU" dirty="0" err="1" smtClean="0"/>
+              <a:rPr lang="ru-RU" dirty="0" err="1"/>
               <a:t>Брауновидон</a:t>
             </a:r>
             <a:r>
-              <a:rPr lang="ru-RU" dirty="0" smtClean="0"/>
+              <a:rPr lang="ru-RU" dirty="0"/>
               <a:t> </a:t>
             </a:r>
             <a:r>
-              <a:rPr lang="ru-RU" dirty="0" err="1" smtClean="0"/>
+              <a:rPr lang="ru-RU" dirty="0" err="1"/>
               <a:t>може</a:t>
             </a:r>
             <a:r>
-              <a:rPr lang="ru-RU" dirty="0" smtClean="0"/>
+              <a:rPr lang="ru-RU" dirty="0"/>
               <a:t> да </a:t>
             </a:r>
             <a:r>
-              <a:rPr lang="ru-RU" dirty="0" err="1" smtClean="0"/>
+              <a:rPr lang="ru-RU" dirty="0" err="1"/>
               <a:t>предизвика</a:t>
             </a:r>
             <a:r>
-              <a:rPr lang="ru-RU" dirty="0" smtClean="0"/>
+              <a:rPr lang="ru-RU" dirty="0"/>
               <a:t> </a:t>
             </a:r>
             <a:r>
-              <a:rPr lang="ru-RU" dirty="0" err="1" smtClean="0"/>
+              <a:rPr lang="ru-RU" dirty="0" err="1"/>
               <a:t>нежелани</a:t>
             </a:r>
             <a:r>
-              <a:rPr lang="ru-RU" dirty="0" smtClean="0"/>
+              <a:rPr lang="ru-RU" dirty="0"/>
               <a:t> реакции, </a:t>
             </a:r>
             <a:r>
-              <a:rPr lang="ru-RU" dirty="0" err="1" smtClean="0"/>
+              <a:rPr lang="ru-RU" dirty="0" err="1"/>
               <a:t>въпреки</a:t>
             </a:r>
             <a:r>
-              <a:rPr lang="ru-RU" dirty="0" smtClean="0"/>
+              <a:rPr lang="ru-RU" dirty="0"/>
               <a:t> че не </a:t>
             </a:r>
             <a:r>
-              <a:rPr lang="ru-RU" dirty="0" err="1" smtClean="0"/>
+              <a:rPr lang="ru-RU" dirty="0" err="1"/>
               <a:t>всеки</a:t>
             </a:r>
             <a:r>
-              <a:rPr lang="ru-RU" dirty="0" smtClean="0"/>
+              <a:rPr lang="ru-RU" dirty="0"/>
               <a:t> </a:t>
             </a:r>
             <a:r>
-              <a:rPr lang="ru-RU" dirty="0" err="1" smtClean="0"/>
+              <a:rPr lang="ru-RU" dirty="0" err="1"/>
               <a:t>ги</a:t>
             </a:r>
             <a:r>
-              <a:rPr lang="ru-RU" dirty="0" smtClean="0"/>
+              <a:rPr lang="ru-RU" dirty="0"/>
               <a:t> </a:t>
             </a:r>
             <a:r>
-              <a:rPr lang="ru-RU" dirty="0" err="1" smtClean="0"/>
+              <a:rPr lang="ru-RU" dirty="0" err="1"/>
               <a:t>получава</a:t>
             </a:r>
             <a:r>
-              <a:rPr lang="ru-RU" dirty="0" smtClean="0"/>
-              <a:t>…</a:t>
-            </a:r>
-            <a:r>
               <a:rPr lang="ru-RU" dirty="0"/>
-              <a:t>  },</a:t>
+              <a:t>…  },</a:t>
             </a:r>
           </a:p>
         </p:txBody>
@@ -10951,23 +11053,23 @@
               <a:buChar char="Ø"/>
             </a:pPr>
             <a:r>
-              <a:rPr lang="bg-BG" dirty="0" smtClean="0"/>
+              <a:rPr lang="bg-BG" dirty="0"/>
               <a:t>Разделяне на секция на подсекции с  максимална дължина 1</a:t>
             </a:r>
             <a:r>
-              <a:rPr lang="en-US" dirty="0" smtClean="0"/>
+              <a:rPr lang="en-US" dirty="0"/>
               <a:t>0</a:t>
             </a:r>
             <a:r>
-              <a:rPr lang="bg-BG" dirty="0" smtClean="0"/>
+              <a:rPr lang="bg-BG" dirty="0"/>
               <a:t>00 символа</a:t>
             </a:r>
             <a:r>
-              <a:rPr lang="en-US" dirty="0" smtClean="0"/>
+              <a:rPr lang="en-US" dirty="0"/>
               <a:t>, </a:t>
             </a:r>
             <a:r>
-              <a:rPr lang="bg-BG" dirty="0" smtClean="0"/>
+              <a:rPr lang="bg-BG" dirty="0"/>
               <a:t>за по-бързо четене от генериращия модел.</a:t>
             </a:r>
           </a:p>
@@ -10977,15 +11079,15 @@
               <a:buChar char="Ø"/>
             </a:pPr>
             <a:r>
-              <a:rPr lang="bg-BG" dirty="0" smtClean="0"/>
+              <a:rPr lang="bg-BG" dirty="0"/>
               <a:t>Използване на 100 символа припокриване между подсекции</a:t>
             </a:r>
             <a:r>
-              <a:rPr lang="en-US" dirty="0" smtClean="0"/>
+              <a:rPr lang="en-US" dirty="0"/>
               <a:t>, </a:t>
             </a:r>
             <a:r>
-              <a:rPr lang="bg-BG" dirty="0" smtClean="0"/>
+              <a:rPr lang="bg-BG" dirty="0"/>
               <a:t>за да не се отреже важна информация.</a:t>
             </a:r>
           </a:p>
@@ -10995,7 +11097,7 @@
               <a:buChar char="Ø"/>
             </a:pPr>
             <a:r>
-              <a:rPr lang="bg-BG" dirty="0" smtClean="0"/>
+              <a:rPr lang="bg-BG" dirty="0"/>
               <a:t>Съхраняване на подходящи метаданни за всяка подсекция</a:t>
             </a:r>
             <a:r>
@@ -11062,13 +11164,18 @@
   <p:clrMapOvr>
     <a:masterClrMapping/>
   </p:clrMapOvr>
-  <p:timing>
-    <p:tnLst>
-      <p:par>
-        <p:cTn id="1" dur="indefinite" restart="never" nodeType="tmRoot"/>
-      </p:par>
-    </p:tnLst>
-  </p:timing>
+  <mc:AlternateContent xmlns:mc="http://schemas.openxmlformats.org/markup-compatibility/2006">
+    <mc:Choice xmlns:p15="http://schemas.microsoft.com/office/powerpoint/2012/main" Requires="p15">
+      <p:transition xmlns:p14="http://schemas.microsoft.com/office/powerpoint/2010/main" spd="slow" p14:dur="1250">
+        <p15:prstTrans prst="pageCurlDouble"/>
+      </p:transition>
+    </mc:Choice>
+    <mc:Fallback>
+      <p:transition spd="slow">
+        <p:fade/>
+      </p:transition>
+    </mc:Fallback>
+  </mc:AlternateContent>
 </p:sld>
 </file>
 
@@ -11105,7 +11212,7 @@
           <a:lstStyle/>
           <a:p>
             <a:r>
-              <a:rPr lang="en-US" dirty="0" err="1" smtClean="0"/>
+              <a:rPr lang="en-US" dirty="0" err="1"/>
               <a:t>Embeddings</a:t>
             </a:r>
             <a:endParaRPr lang="bg-BG" dirty="0"/>
@@ -11122,20 +11229,91 @@
             <p:ph idx="1"/>
           </p:nvPr>
         </p:nvSpPr>
-        <p:spPr/>
+        <p:spPr>
+          <a:xfrm>
+            <a:off x="2589212" y="2133600"/>
+            <a:ext cx="7084724" cy="3777622"/>
+          </a:xfrm>
+        </p:spPr>
         <p:txBody>
           <a:bodyPr/>
           <a:lstStyle/>
           <a:p>
             <a:r>
-              <a:rPr lang="en-US" dirty="0" smtClean="0"/>
-              <a:t>// TODO </a:t>
-            </a:r>
-            <a:r>
-              <a:rPr lang="bg-BG" dirty="0" smtClean="0"/>
-              <a:t>СТЕН добави каквото смяташ за нужно тук</a:t>
-            </a:r>
-            <a:endParaRPr lang="bg-BG" dirty="0"/>
+              <a:rPr lang="bg-BG" dirty="0"/>
+              <a:t>Търсене по семантиката на думите вместо по тяхното</a:t>
+            </a:r>
+            <a:r>
+              <a:rPr lang="en-US" dirty="0"/>
+              <a:t> </a:t>
+            </a:r>
+            <a:r>
+              <a:rPr lang="bg-BG" dirty="0"/>
+              <a:t>слово</a:t>
+            </a:r>
+          </a:p>
+          <a:p>
+            <a:r>
+              <a:rPr lang="bg-BG" dirty="0"/>
+              <a:t>Сравнение по косинусова близост</a:t>
+            </a:r>
+            <a:r>
+              <a:rPr lang="en-US" dirty="0"/>
+              <a:t> </a:t>
+            </a:r>
+            <a:r>
+              <a:rPr lang="bg-BG" dirty="0"/>
+              <a:t>с 384-мерни вектори</a:t>
+            </a:r>
+          </a:p>
+          <a:p>
+            <a:r>
+              <a:rPr lang="bg-BG" dirty="0"/>
+              <a:t>Връзка между мета данните и вектор данните</a:t>
+            </a:r>
+            <a:endParaRPr lang="en-US" dirty="0"/>
+          </a:p>
+          <a:p>
+            <a:r>
+              <a:rPr lang="bg-BG" dirty="0"/>
+              <a:t>Избраният модел е достатъчно малък за </a:t>
+            </a:r>
+            <a:r>
+              <a:rPr lang="en-US" dirty="0"/>
+              <a:t>Nearest </a:t>
+            </a:r>
+            <a:r>
+              <a:rPr lang="en-US" dirty="0" err="1"/>
+              <a:t>Neighbour</a:t>
+            </a:r>
+            <a:r>
+              <a:rPr lang="en-US" dirty="0"/>
+              <a:t> (</a:t>
+            </a:r>
+            <a:r>
+              <a:rPr lang="en-US" dirty="0" err="1"/>
+              <a:t>IndexFlatIP</a:t>
+            </a:r>
+            <a:r>
+              <a:rPr lang="en-US" dirty="0"/>
+              <a:t>) </a:t>
+            </a:r>
+            <a:r>
+              <a:rPr lang="bg-BG" dirty="0"/>
+              <a:t>вместо </a:t>
+            </a:r>
+            <a:r>
+              <a:rPr lang="en-US" dirty="0"/>
+              <a:t>Approximate Nearest </a:t>
+            </a:r>
+            <a:r>
+              <a:rPr lang="en-US" dirty="0" err="1"/>
+              <a:t>Neighbour</a:t>
+            </a:r>
+            <a:r>
+              <a:rPr lang="en-US" dirty="0"/>
+              <a:t> (IVF, HNSW)</a:t>
+            </a:r>
           </a:p>
         </p:txBody>
       </p:sp>
@@ -11149,13 +11327,18 @@
   <p:clrMapOvr>
     <a:masterClrMapping/>
   </p:clrMapOvr>
-  <p:timing>
-    <p:tnLst>
-      <p:par>
-        <p:cTn id="1" dur="indefinite" restart="never" nodeType="tmRoot"/>
-      </p:par>
-    </p:tnLst>
-  </p:timing>
+  <mc:AlternateContent xmlns:mc="http://schemas.openxmlformats.org/markup-compatibility/2006">
+    <mc:Choice xmlns:p15="http://schemas.microsoft.com/office/powerpoint/2012/main" Requires="p15">
+      <p:transition xmlns:p14="http://schemas.microsoft.com/office/powerpoint/2010/main" spd="slow" p14:dur="1250">
+        <p15:prstTrans prst="pageCurlDouble"/>
+      </p:transition>
+    </mc:Choice>
+    <mc:Fallback>
+      <p:transition spd="slow">
+        <p:fade/>
+      </p:transition>
+    </mc:Fallback>
+  </mc:AlternateContent>
 </p:sld>
 </file>
 

</xml_diff>

<commit_message>
added "results" to presentation (slide 12)
</commit_message>
<xml_diff>
--- a/rag_presentation.pptx
+++ b/rag_presentation.pptx
@@ -16,12 +16,11 @@
     <p:sldId id="264" r:id="rId10"/>
     <p:sldId id="265" r:id="rId11"/>
     <p:sldId id="266" r:id="rId12"/>
-    <p:sldId id="267" r:id="rId13"/>
-    <p:sldId id="268" r:id="rId14"/>
-    <p:sldId id="269" r:id="rId15"/>
-    <p:sldId id="270" r:id="rId16"/>
-    <p:sldId id="273" r:id="rId17"/>
-    <p:sldId id="272" r:id="rId18"/>
+    <p:sldId id="268" r:id="rId13"/>
+    <p:sldId id="269" r:id="rId14"/>
+    <p:sldId id="270" r:id="rId15"/>
+    <p:sldId id="273" r:id="rId16"/>
+    <p:sldId id="272" r:id="rId17"/>
   </p:sldIdLst>
   <p:sldSz cx="12192000" cy="6858000"/>
   <p:notesSz cx="6858000" cy="9144000"/>
@@ -7983,6 +7982,14 @@
   <p:clrMapOvr>
     <a:masterClrMapping/>
   </p:clrMapOvr>
+  <mc:AlternateContent xmlns:mc="http://schemas.openxmlformats.org/markup-compatibility/2006">
+    <mc:Choice xmlns:p14="http://schemas.microsoft.com/office/powerpoint/2010/main" Requires="p14">
+      <p:transition spd="slow" p14:dur="2000"/>
+    </mc:Choice>
+    <mc:Fallback>
+      <p:transition spd="slow"/>
+    </mc:Fallback>
+  </mc:AlternateContent>
 </p:sld>
 </file>
 
@@ -8061,13 +8068,13 @@
   <p:clrMapOvr>
     <a:masterClrMapping/>
   </p:clrMapOvr>
-  <mc:AlternateContent xmlns:mc="http://schemas.openxmlformats.org/markup-compatibility/2006">
-    <mc:Choice xmlns:p15="http://schemas.microsoft.com/office/powerpoint/2012/main" Requires="p15">
+  <mc:AlternateContent xmlns:mc="http://schemas.openxmlformats.org/markup-compatibility/2006" xmlns:p15="http://schemas.microsoft.com/office/powerpoint/2012/main">
+    <mc:Choice Requires="p15">
       <p:transition xmlns:p14="http://schemas.microsoft.com/office/powerpoint/2010/main" spd="slow" p14:dur="1250">
         <p15:prstTrans prst="pageCurlDouble"/>
       </p:transition>
     </mc:Choice>
-    <mc:Fallback>
+    <mc:Fallback xmlns="">
       <p:transition spd="slow">
         <p:fade/>
       </p:transition>
@@ -8116,6 +8123,10 @@
             <a:r>
               <a:rPr lang="bg-BG" dirty="0"/>
               <a:t>Използвани технологии</a:t>
+            </a:r>
+            <a:r>
+              <a:rPr lang="en-US" dirty="0"/>
+              <a:t/>
             </a:r>
             <a:br>
               <a:rPr lang="en-US" dirty="0"/>
@@ -8550,13 +8561,13 @@
   <p:clrMapOvr>
     <a:masterClrMapping/>
   </p:clrMapOvr>
-  <mc:AlternateContent xmlns:mc="http://schemas.openxmlformats.org/markup-compatibility/2006">
-    <mc:Choice xmlns:p14="http://schemas.microsoft.com/office/powerpoint/2010/main" Requires="p14">
+  <mc:AlternateContent xmlns:mc="http://schemas.openxmlformats.org/markup-compatibility/2006" xmlns:p14="http://schemas.microsoft.com/office/powerpoint/2010/main">
+    <mc:Choice Requires="p14">
       <p:transition spd="slow" p14:dur="1250">
         <p14:switch dir="r"/>
       </p:transition>
     </mc:Choice>
-    <mc:Fallback>
+    <mc:Fallback xmlns="">
       <p:transition spd="slow">
         <p:fade/>
       </p:transition>
@@ -8599,132 +8610,482 @@
           <a:p>
             <a:r>
               <a:rPr lang="bg-BG" dirty="0"/>
-              <a:t>Резултати</a:t>
-            </a:r>
-          </a:p>
-        </p:txBody>
-      </p:sp>
-      <p:sp>
-        <p:nvSpPr>
-          <p:cNvPr id="3" name="Content Placeholder 2"/>
-          <p:cNvSpPr>
-            <a:spLocks noGrp="1"/>
-          </p:cNvSpPr>
+              <a:t>Сравнение на подходи</a:t>
+            </a:r>
+          </a:p>
+        </p:txBody>
+      </p:sp>
+      <p:graphicFrame>
+        <p:nvGraphicFramePr>
+          <p:cNvPr id="4" name="Content Placeholder 3"/>
+          <p:cNvGraphicFramePr>
+            <a:graphicFrameLocks noGrp="1"/>
+          </p:cNvGraphicFramePr>
           <p:nvPr>
             <p:ph idx="1"/>
-          </p:nvPr>
-        </p:nvSpPr>
-        <p:spPr/>
-        <p:txBody>
-          <a:bodyPr/>
-          <a:lstStyle/>
-          <a:p>
-            <a:r>
-              <a:rPr lang="en-US" dirty="0"/>
-              <a:t>// TODO – </a:t>
-            </a:r>
-            <a:r>
-              <a:rPr lang="bg-BG" dirty="0" err="1"/>
-              <a:t>скрийншоти</a:t>
-            </a:r>
-            <a:r>
-              <a:rPr lang="en-US" dirty="0"/>
-              <a:t>/</a:t>
-            </a:r>
-            <a:r>
-              <a:rPr lang="bg-BG" dirty="0"/>
-              <a:t>копирани примерни </a:t>
-            </a:r>
-            <a:r>
-              <a:rPr lang="bg-BG" dirty="0" err="1"/>
-              <a:t>промптове</a:t>
-            </a:r>
-            <a:r>
-              <a:rPr lang="bg-BG" dirty="0"/>
-              <a:t> с отговори </a:t>
-            </a:r>
-            <a:r>
-              <a:rPr lang="en-US" dirty="0"/>
-              <a:t>(</a:t>
-            </a:r>
-            <a:r>
-              <a:rPr lang="bg-BG" dirty="0"/>
-              <a:t>според </a:t>
-            </a:r>
-            <a:r>
-              <a:rPr lang="en-US" dirty="0" err="1"/>
-              <a:t>gpt</a:t>
-            </a:r>
-            <a:r>
-              <a:rPr lang="en-US" dirty="0"/>
-              <a:t> </a:t>
-            </a:r>
-            <a:r>
-              <a:rPr lang="bg-BG" dirty="0"/>
-              <a:t>може графики за </a:t>
-            </a:r>
-            <a:r>
-              <a:rPr lang="en-US" dirty="0"/>
-              <a:t>precision, recall</a:t>
-            </a:r>
-            <a:r>
-              <a:rPr lang="bg-BG" dirty="0"/>
-              <a:t> ама ние като не знаем за всеки въпрос точния отговор</a:t>
-            </a:r>
-            <a:r>
-              <a:rPr lang="en-US" dirty="0"/>
-              <a:t> </a:t>
-            </a:r>
-            <a:r>
-              <a:rPr lang="bg-BG" dirty="0"/>
-              <a:t>става трудно – може би с въпроси от типа </a:t>
-            </a:r>
-            <a:r>
-              <a:rPr lang="en-US" dirty="0"/>
-              <a:t>“</a:t>
-            </a:r>
-            <a:r>
-              <a:rPr lang="bg-BG" dirty="0"/>
-              <a:t>как се приема </a:t>
-            </a:r>
-            <a:r>
-              <a:rPr lang="en-US" dirty="0"/>
-              <a:t>[</a:t>
-            </a:r>
-            <a:r>
-              <a:rPr lang="bg-BG" dirty="0"/>
-              <a:t>име на лекарство</a:t>
-            </a:r>
-            <a:r>
-              <a:rPr lang="en-US" dirty="0"/>
-              <a:t>]?”)</a:t>
-            </a:r>
-            <a:endParaRPr lang="bg-BG" dirty="0"/>
-          </a:p>
-        </p:txBody>
-      </p:sp>
+            <p:extLst>
+              <p:ext uri="{D42A27DB-BD31-4B8C-83A1-F6EECF244321}">
+                <p14:modId xmlns:p14="http://schemas.microsoft.com/office/powerpoint/2010/main" val="1750573961"/>
+              </p:ext>
+            </p:extLst>
+          </p:nvPr>
+        </p:nvGraphicFramePr>
+        <p:xfrm>
+          <a:off x="1670181" y="1334278"/>
+          <a:ext cx="9638520" cy="4787198"/>
+        </p:xfrm>
+        <a:graphic>
+          <a:graphicData uri="http://schemas.openxmlformats.org/drawingml/2006/table">
+            <a:tbl>
+              <a:tblPr firstRow="1" bandRow="1">
+                <a:tableStyleId>{5C22544A-7EE6-4342-B048-85BDC9FD1C3A}</a:tableStyleId>
+              </a:tblPr>
+              <a:tblGrid>
+                <a:gridCol w="3212840">
+                  <a:extLst>
+                    <a:ext uri="{9D8B030D-6E8A-4147-A177-3AD203B41FA5}">
+                      <a16:colId xmlns:a16="http://schemas.microsoft.com/office/drawing/2014/main" val="583244453"/>
+                    </a:ext>
+                  </a:extLst>
+                </a:gridCol>
+                <a:gridCol w="3212840">
+                  <a:extLst>
+                    <a:ext uri="{9D8B030D-6E8A-4147-A177-3AD203B41FA5}">
+                      <a16:colId xmlns:a16="http://schemas.microsoft.com/office/drawing/2014/main" val="559079376"/>
+                    </a:ext>
+                  </a:extLst>
+                </a:gridCol>
+                <a:gridCol w="3212840">
+                  <a:extLst>
+                    <a:ext uri="{9D8B030D-6E8A-4147-A177-3AD203B41FA5}">
+                      <a16:colId xmlns:a16="http://schemas.microsoft.com/office/drawing/2014/main" val="4213334542"/>
+                    </a:ext>
+                  </a:extLst>
+                </a:gridCol>
+              </a:tblGrid>
+              <a:tr h="950031">
+                <a:tc>
+                  <a:txBody>
+                    <a:bodyPr/>
+                    <a:lstStyle/>
+                    <a:p>
+                      <a:r>
+                        <a:rPr lang="bg-BG" dirty="0" smtClean="0"/>
+                        <a:t>Компонент</a:t>
+                      </a:r>
+                      <a:endParaRPr lang="bg-BG" dirty="0"/>
+                    </a:p>
+                  </a:txBody>
+                  <a:tcPr/>
+                </a:tc>
+                <a:tc>
+                  <a:txBody>
+                    <a:bodyPr/>
+                    <a:lstStyle/>
+                    <a:p>
+                      <a:r>
+                        <a:rPr lang="bg-BG" dirty="0" smtClean="0"/>
+                        <a:t>Стратегия</a:t>
+                      </a:r>
+                      <a:endParaRPr lang="bg-BG" dirty="0"/>
+                    </a:p>
+                  </a:txBody>
+                  <a:tcPr/>
+                </a:tc>
+                <a:tc>
+                  <a:txBody>
+                    <a:bodyPr/>
+                    <a:lstStyle/>
+                    <a:p>
+                      <a:r>
+                        <a:rPr lang="bg-BG" dirty="0" smtClean="0"/>
+                        <a:t>Резултат</a:t>
+                      </a:r>
+                      <a:endParaRPr lang="bg-BG" dirty="0"/>
+                    </a:p>
+                  </a:txBody>
+                  <a:tcPr/>
+                </a:tc>
+                <a:extLst>
+                  <a:ext uri="{0D108BD9-81ED-4DB2-BD59-A6C34878D82A}">
+                    <a16:rowId xmlns:a16="http://schemas.microsoft.com/office/drawing/2014/main" val="3641608381"/>
+                  </a:ext>
+                </a:extLst>
+              </a:tr>
+              <a:tr h="1094819">
+                <a:tc>
+                  <a:txBody>
+                    <a:bodyPr/>
+                    <a:lstStyle/>
+                    <a:p>
+                      <a:r>
+                        <a:rPr lang="bg-BG" dirty="0" smtClean="0"/>
+                        <a:t>Разделяне</a:t>
+                      </a:r>
+                      <a:r>
+                        <a:rPr lang="bg-BG" baseline="0" dirty="0" smtClean="0"/>
+                        <a:t> на текста</a:t>
+                      </a:r>
+                      <a:endParaRPr lang="bg-BG" dirty="0"/>
+                    </a:p>
+                  </a:txBody>
+                  <a:tcPr/>
+                </a:tc>
+                <a:tc>
+                  <a:txBody>
+                    <a:bodyPr/>
+                    <a:lstStyle/>
+                    <a:p>
+                      <a:r>
+                        <a:rPr lang="bg-BG" dirty="0" smtClean="0"/>
+                        <a:t>Разделяне</a:t>
+                      </a:r>
+                      <a:r>
+                        <a:rPr lang="bg-BG" baseline="0" dirty="0" smtClean="0"/>
+                        <a:t> на документите само по секции</a:t>
+                      </a:r>
+                      <a:endParaRPr lang="bg-BG" dirty="0"/>
+                    </a:p>
+                  </a:txBody>
+                  <a:tcPr/>
+                </a:tc>
+                <a:tc>
+                  <a:txBody>
+                    <a:bodyPr/>
+                    <a:lstStyle/>
+                    <a:p>
+                      <a:r>
+                        <a:rPr lang="ru-RU" dirty="0" err="1" smtClean="0"/>
+                        <a:t>По-голяма</a:t>
+                      </a:r>
+                      <a:r>
+                        <a:rPr lang="ru-RU" dirty="0" smtClean="0"/>
+                        <a:t> </a:t>
+                      </a:r>
+                      <a:r>
+                        <a:rPr lang="ru-RU" dirty="0" err="1" smtClean="0"/>
+                        <a:t>вероятност</a:t>
+                      </a:r>
+                      <a:r>
+                        <a:rPr lang="ru-RU" dirty="0" smtClean="0"/>
+                        <a:t> в </a:t>
+                      </a:r>
+                      <a:r>
+                        <a:rPr lang="ru-RU" dirty="0" err="1" smtClean="0"/>
+                        <a:t>chunk</a:t>
+                      </a:r>
+                      <a:r>
+                        <a:rPr lang="ru-RU" dirty="0" smtClean="0"/>
+                        <a:t>-а да </a:t>
+                      </a:r>
+                      <a:r>
+                        <a:rPr lang="ru-RU" dirty="0" err="1" smtClean="0"/>
+                        <a:t>има</a:t>
+                      </a:r>
+                      <a:r>
+                        <a:rPr lang="ru-RU" dirty="0" smtClean="0"/>
+                        <a:t> </a:t>
+                      </a:r>
+                      <a:r>
+                        <a:rPr lang="ru-RU" dirty="0" err="1" smtClean="0"/>
+                        <a:t>смесена</a:t>
+                      </a:r>
+                      <a:r>
+                        <a:rPr lang="ru-RU" dirty="0" smtClean="0"/>
+                        <a:t> и частично </a:t>
+                      </a:r>
+                      <a:r>
+                        <a:rPr lang="ru-RU" dirty="0" err="1" smtClean="0"/>
+                        <a:t>нерелевантна</a:t>
+                      </a:r>
+                      <a:r>
+                        <a:rPr lang="ru-RU" dirty="0" smtClean="0"/>
+                        <a:t> информация</a:t>
+                      </a:r>
+                      <a:endParaRPr lang="bg-BG" dirty="0"/>
+                    </a:p>
+                  </a:txBody>
+                  <a:tcPr/>
+                </a:tc>
+                <a:extLst>
+                  <a:ext uri="{0D108BD9-81ED-4DB2-BD59-A6C34878D82A}">
+                    <a16:rowId xmlns:a16="http://schemas.microsoft.com/office/drawing/2014/main" val="1253202445"/>
+                  </a:ext>
+                </a:extLst>
+              </a:tr>
+              <a:tr h="684857">
+                <a:tc>
+                  <a:txBody>
+                    <a:bodyPr/>
+                    <a:lstStyle/>
+                    <a:p>
+                      <a:r>
+                        <a:rPr lang="bg-BG" dirty="0" smtClean="0"/>
+                        <a:t>Разделяне на текста</a:t>
+                      </a:r>
+                      <a:endParaRPr lang="bg-BG" dirty="0"/>
+                    </a:p>
+                  </a:txBody>
+                  <a:tcPr/>
+                </a:tc>
+                <a:tc>
+                  <a:txBody>
+                    <a:bodyPr/>
+                    <a:lstStyle/>
+                    <a:p>
+                      <a:r>
+                        <a:rPr lang="bg-BG" dirty="0" smtClean="0"/>
+                        <a:t>Разделяне на секциите на подсекции</a:t>
+                      </a:r>
+                      <a:endParaRPr lang="bg-BG" dirty="0"/>
+                    </a:p>
+                  </a:txBody>
+                  <a:tcPr/>
+                </a:tc>
+                <a:tc>
+                  <a:txBody>
+                    <a:bodyPr/>
+                    <a:lstStyle/>
+                    <a:p>
+                      <a:r>
+                        <a:rPr lang="ru-RU" dirty="0" err="1" smtClean="0"/>
+                        <a:t>По-прецизно</a:t>
+                      </a:r>
+                      <a:r>
+                        <a:rPr lang="ru-RU" dirty="0" smtClean="0"/>
+                        <a:t> </a:t>
+                      </a:r>
+                      <a:r>
+                        <a:rPr lang="ru-RU" dirty="0" err="1" smtClean="0"/>
+                        <a:t>извличане</a:t>
+                      </a:r>
+                      <a:r>
+                        <a:rPr lang="ru-RU" dirty="0" smtClean="0"/>
+                        <a:t> на </a:t>
+                      </a:r>
+                      <a:r>
+                        <a:rPr lang="ru-RU" dirty="0" err="1" smtClean="0"/>
+                        <a:t>релевантни</a:t>
+                      </a:r>
+                      <a:r>
+                        <a:rPr lang="ru-RU" dirty="0" smtClean="0"/>
+                        <a:t> </a:t>
+                      </a:r>
+                      <a:r>
+                        <a:rPr lang="ru-RU" dirty="0" err="1" smtClean="0"/>
+                        <a:t>пасажи</a:t>
+                      </a:r>
+                      <a:endParaRPr lang="bg-BG" dirty="0"/>
+                    </a:p>
+                  </a:txBody>
+                  <a:tcPr/>
+                </a:tc>
+                <a:extLst>
+                  <a:ext uri="{0D108BD9-81ED-4DB2-BD59-A6C34878D82A}">
+                    <a16:rowId xmlns:a16="http://schemas.microsoft.com/office/drawing/2014/main" val="3395144959"/>
+                  </a:ext>
+                </a:extLst>
+              </a:tr>
+              <a:tr h="1013559">
+                <a:tc>
+                  <a:txBody>
+                    <a:bodyPr/>
+                    <a:lstStyle/>
+                    <a:p>
+                      <a:r>
+                        <a:rPr lang="bg-BG" dirty="0" smtClean="0"/>
+                        <a:t>Генеративен</a:t>
+                      </a:r>
+                      <a:r>
+                        <a:rPr lang="bg-BG" baseline="0" dirty="0" smtClean="0"/>
+                        <a:t> модел</a:t>
+                      </a:r>
+                      <a:endParaRPr lang="bg-BG" dirty="0"/>
+                    </a:p>
+                  </a:txBody>
+                  <a:tcPr/>
+                </a:tc>
+                <a:tc>
+                  <a:txBody>
+                    <a:bodyPr/>
+                    <a:lstStyle/>
+                    <a:p>
+                      <a:r>
+                        <a:rPr lang="en-US" dirty="0" smtClean="0"/>
+                        <a:t>Llama3 (1B</a:t>
+                      </a:r>
+                      <a:r>
+                        <a:rPr lang="en-US" baseline="0" dirty="0" smtClean="0"/>
+                        <a:t> </a:t>
+                      </a:r>
+                      <a:r>
+                        <a:rPr lang="bg-BG" baseline="0" dirty="0" err="1" smtClean="0"/>
+                        <a:t>парам</a:t>
+                      </a:r>
+                      <a:r>
+                        <a:rPr lang="bg-BG" baseline="0" dirty="0" smtClean="0"/>
+                        <a:t>.</a:t>
+                      </a:r>
+                      <a:r>
+                        <a:rPr lang="en-US" dirty="0" smtClean="0"/>
+                        <a:t>)</a:t>
+                      </a:r>
+                      <a:endParaRPr lang="bg-BG" dirty="0"/>
+                    </a:p>
+                  </a:txBody>
+                  <a:tcPr/>
+                </a:tc>
+                <a:tc>
+                  <a:txBody>
+                    <a:bodyPr/>
+                    <a:lstStyle/>
+                    <a:p>
+                      <a:r>
+                        <a:rPr lang="ru-RU" dirty="0" err="1" smtClean="0"/>
+                        <a:t>По-слабо</a:t>
+                      </a:r>
+                      <a:r>
+                        <a:rPr lang="ru-RU" dirty="0" smtClean="0"/>
+                        <a:t> </a:t>
+                      </a:r>
+                      <a:r>
+                        <a:rPr lang="ru-RU" dirty="0" err="1" smtClean="0"/>
+                        <a:t>следване</a:t>
+                      </a:r>
+                      <a:r>
+                        <a:rPr lang="ru-RU" dirty="0" smtClean="0"/>
+                        <a:t> на инструкции и </a:t>
+                      </a:r>
+                      <a:r>
+                        <a:rPr lang="ru-RU" dirty="0" err="1" smtClean="0"/>
+                        <a:t>по-ниско</a:t>
+                      </a:r>
+                      <a:r>
+                        <a:rPr lang="ru-RU" dirty="0" smtClean="0"/>
+                        <a:t> качество на </a:t>
+                      </a:r>
+                      <a:r>
+                        <a:rPr lang="ru-RU" dirty="0" err="1" smtClean="0"/>
+                        <a:t>цитирането</a:t>
+                      </a:r>
+                      <a:endParaRPr lang="bg-BG" dirty="0"/>
+                    </a:p>
+                  </a:txBody>
+                  <a:tcPr/>
+                </a:tc>
+                <a:extLst>
+                  <a:ext uri="{0D108BD9-81ED-4DB2-BD59-A6C34878D82A}">
+                    <a16:rowId xmlns:a16="http://schemas.microsoft.com/office/drawing/2014/main" val="1160364636"/>
+                  </a:ext>
+                </a:extLst>
+              </a:tr>
+              <a:tr h="950031">
+                <a:tc>
+                  <a:txBody>
+                    <a:bodyPr/>
+                    <a:lstStyle/>
+                    <a:p>
+                      <a:r>
+                        <a:rPr lang="bg-BG" dirty="0" smtClean="0"/>
+                        <a:t>Генеративен модел</a:t>
+                      </a:r>
+                      <a:endParaRPr lang="bg-BG" dirty="0"/>
+                    </a:p>
+                  </a:txBody>
+                  <a:tcPr/>
+                </a:tc>
+                <a:tc>
+                  <a:txBody>
+                    <a:bodyPr/>
+                    <a:lstStyle/>
+                    <a:p>
+                      <a:r>
+                        <a:rPr lang="en-US" dirty="0" smtClean="0"/>
+                        <a:t>Gemma3</a:t>
+                      </a:r>
+                      <a:r>
+                        <a:rPr lang="en-US" baseline="0" dirty="0" smtClean="0"/>
+                        <a:t> (4B </a:t>
+                      </a:r>
+                      <a:r>
+                        <a:rPr lang="bg-BG" baseline="0" dirty="0" err="1" smtClean="0"/>
+                        <a:t>парам</a:t>
+                      </a:r>
+                      <a:r>
+                        <a:rPr lang="bg-BG" baseline="0" dirty="0" smtClean="0"/>
+                        <a:t>.</a:t>
+                      </a:r>
+                      <a:r>
+                        <a:rPr lang="en-US" baseline="0" dirty="0" smtClean="0"/>
+                        <a:t>)</a:t>
+                      </a:r>
+                      <a:endParaRPr lang="bg-BG" dirty="0"/>
+                    </a:p>
+                  </a:txBody>
+                  <a:tcPr/>
+                </a:tc>
+                <a:tc>
+                  <a:txBody>
+                    <a:bodyPr/>
+                    <a:lstStyle/>
+                    <a:p>
+                      <a:r>
+                        <a:rPr lang="ru-RU" dirty="0" err="1" smtClean="0"/>
+                        <a:t>По-добро</a:t>
+                      </a:r>
+                      <a:r>
+                        <a:rPr lang="ru-RU" dirty="0" smtClean="0"/>
+                        <a:t> </a:t>
+                      </a:r>
+                      <a:r>
+                        <a:rPr lang="ru-RU" dirty="0" err="1" smtClean="0"/>
+                        <a:t>следване</a:t>
+                      </a:r>
+                      <a:r>
+                        <a:rPr lang="ru-RU" dirty="0" smtClean="0"/>
+                        <a:t> на инструкции и </a:t>
+                      </a:r>
+                      <a:r>
+                        <a:rPr lang="ru-RU" dirty="0" err="1" smtClean="0"/>
+                        <a:t>по-добро</a:t>
+                      </a:r>
+                      <a:r>
+                        <a:rPr lang="ru-RU" baseline="0" dirty="0" smtClean="0"/>
+                        <a:t> </a:t>
+                      </a:r>
+                      <a:r>
+                        <a:rPr lang="ru-RU" dirty="0" err="1" smtClean="0"/>
+                        <a:t>използване</a:t>
+                      </a:r>
+                      <a:r>
+                        <a:rPr lang="ru-RU" dirty="0" smtClean="0"/>
+                        <a:t> на контекста</a:t>
+                      </a:r>
+                      <a:endParaRPr lang="bg-BG" dirty="0"/>
+                    </a:p>
+                  </a:txBody>
+                  <a:tcPr/>
+                </a:tc>
+                <a:extLst>
+                  <a:ext uri="{0D108BD9-81ED-4DB2-BD59-A6C34878D82A}">
+                    <a16:rowId xmlns:a16="http://schemas.microsoft.com/office/drawing/2014/main" val="1057666363"/>
+                  </a:ext>
+                </a:extLst>
+              </a:tr>
+            </a:tbl>
+          </a:graphicData>
+        </a:graphic>
+      </p:graphicFrame>
     </p:spTree>
     <p:extLst>
       <p:ext uri="{BB962C8B-B14F-4D97-AF65-F5344CB8AC3E}">
-        <p14:creationId xmlns:p14="http://schemas.microsoft.com/office/powerpoint/2010/main" val="962758335"/>
+        <p14:creationId xmlns:p14="http://schemas.microsoft.com/office/powerpoint/2010/main" val="4249882266"/>
       </p:ext>
     </p:extLst>
   </p:cSld>
   <p:clrMapOvr>
     <a:masterClrMapping/>
   </p:clrMapOvr>
-  <mc:AlternateContent xmlns:mc="http://schemas.openxmlformats.org/markup-compatibility/2006">
-    <mc:Choice xmlns:p15="http://schemas.microsoft.com/office/powerpoint/2012/main" Requires="p15">
-      <p:transition xmlns:p14="http://schemas.microsoft.com/office/powerpoint/2010/main" spd="slow" p14:dur="2000">
-        <p15:prstTrans prst="drape"/>
-      </p:transition>
-    </mc:Choice>
-    <mc:Fallback>
-      <p:transition spd="slow">
-        <p:fade/>
-      </p:transition>
-    </mc:Fallback>
-  </mc:AlternateContent>
 </p:sld>
 </file>
 
@@ -8762,7 +9123,7 @@
           <a:p>
             <a:r>
               <a:rPr lang="bg-BG" dirty="0"/>
-              <a:t>Сравнение на подходи</a:t>
+              <a:t>Недостатъци</a:t>
             </a:r>
           </a:p>
         </p:txBody>
@@ -8777,55 +9138,111 @@
             <p:ph idx="1"/>
           </p:nvPr>
         </p:nvSpPr>
-        <p:spPr/>
+        <p:spPr>
+          <a:xfrm>
+            <a:off x="2592925" y="2282890"/>
+            <a:ext cx="8915400" cy="3777622"/>
+          </a:xfrm>
+        </p:spPr>
         <p:txBody>
           <a:bodyPr/>
           <a:lstStyle/>
           <a:p>
-            <a:r>
-              <a:rPr lang="en-US" dirty="0"/>
-              <a:t>// TODO: </a:t>
-            </a:r>
-            <a:r>
-              <a:rPr lang="bg-BG" dirty="0"/>
-              <a:t>Според </a:t>
-            </a:r>
-            <a:r>
-              <a:rPr lang="en-US" dirty="0"/>
-              <a:t>GPT </a:t>
-            </a:r>
-            <a:r>
-              <a:rPr lang="bg-BG" dirty="0"/>
-              <a:t>тук да кажем кога е по-добър резултата и кога по-лош </a:t>
-            </a:r>
-            <a:r>
-              <a:rPr lang="en-US" dirty="0"/>
-              <a:t>(</a:t>
-            </a:r>
-            <a:r>
-              <a:rPr lang="bg-BG" dirty="0"/>
-              <a:t>например ако променим цепенето на данните</a:t>
-            </a:r>
-            <a:r>
-              <a:rPr lang="en-US" dirty="0"/>
-              <a:t>, </a:t>
-            </a:r>
-            <a:r>
-              <a:rPr lang="bg-BG" dirty="0"/>
-              <a:t>или ако опитваме с различни модели</a:t>
-            </a:r>
-            <a:r>
-              <a:rPr lang="en-US" dirty="0"/>
-              <a:t>)</a:t>
-            </a:r>
-            <a:endParaRPr lang="bg-BG" dirty="0"/>
+            <a:pPr>
+              <a:buFont typeface="Wingdings" panose="05000000000000000000" pitchFamily="2" charset="2"/>
+              <a:buChar char="Ø"/>
+            </a:pPr>
+            <a:r>
+              <a:rPr lang="ru-RU" dirty="0" err="1"/>
+              <a:t>Някои</a:t>
+            </a:r>
+            <a:r>
+              <a:rPr lang="ru-RU" dirty="0"/>
+              <a:t> PDF </a:t>
+            </a:r>
+            <a:r>
+              <a:rPr lang="ru-RU" dirty="0" err="1"/>
+              <a:t>файлове</a:t>
+            </a:r>
+            <a:r>
+              <a:rPr lang="ru-RU" dirty="0"/>
+              <a:t> се </a:t>
+            </a:r>
+            <a:r>
+              <a:rPr lang="ru-RU" dirty="0" err="1"/>
+              <a:t>извличат</a:t>
+            </a:r>
+            <a:r>
+              <a:rPr lang="ru-RU" dirty="0"/>
+              <a:t> </a:t>
+            </a:r>
+            <a:r>
+              <a:rPr lang="ru-RU" dirty="0" err="1"/>
+              <a:t>лошо</a:t>
+            </a:r>
+            <a:r>
+              <a:rPr lang="ru-RU" dirty="0"/>
+              <a:t>. </a:t>
+            </a:r>
+          </a:p>
+          <a:p>
+            <a:pPr>
+              <a:buFont typeface="Wingdings" panose="05000000000000000000" pitchFamily="2" charset="2"/>
+              <a:buChar char="Ø"/>
+            </a:pPr>
+            <a:r>
+              <a:rPr lang="ru-RU" dirty="0" err="1"/>
+              <a:t>Системата</a:t>
+            </a:r>
+            <a:r>
+              <a:rPr lang="ru-RU" dirty="0"/>
+              <a:t> не </a:t>
+            </a:r>
+            <a:r>
+              <a:rPr lang="ru-RU" dirty="0" err="1"/>
+              <a:t>замества</a:t>
+            </a:r>
+            <a:r>
+              <a:rPr lang="ru-RU" dirty="0"/>
+              <a:t> </a:t>
+            </a:r>
+            <a:r>
+              <a:rPr lang="ru-RU" dirty="0" err="1"/>
+              <a:t>лекар</a:t>
+            </a:r>
+            <a:r>
+              <a:rPr lang="ru-RU" dirty="0"/>
+              <a:t>. </a:t>
+            </a:r>
+          </a:p>
+          <a:p>
+            <a:pPr>
+              <a:buFont typeface="Wingdings" panose="05000000000000000000" pitchFamily="2" charset="2"/>
+              <a:buChar char="Ø"/>
+            </a:pPr>
+            <a:r>
+              <a:rPr lang="ru-RU" dirty="0" err="1"/>
+              <a:t>Възможни</a:t>
+            </a:r>
+            <a:r>
+              <a:rPr lang="ru-RU" dirty="0"/>
+              <a:t> </a:t>
+            </a:r>
+            <a:r>
+              <a:rPr lang="ru-RU" dirty="0" err="1"/>
+              <a:t>халюцинации</a:t>
+            </a:r>
+            <a:r>
+              <a:rPr lang="ru-RU" dirty="0"/>
+              <a:t> на LLM.</a:t>
+            </a:r>
           </a:p>
         </p:txBody>
       </p:sp>
     </p:spTree>
     <p:extLst>
       <p:ext uri="{BB962C8B-B14F-4D97-AF65-F5344CB8AC3E}">
-        <p14:creationId xmlns:p14="http://schemas.microsoft.com/office/powerpoint/2010/main" val="4249882266"/>
+        <p14:creationId xmlns:p14="http://schemas.microsoft.com/office/powerpoint/2010/main" val="664100836"/>
       </p:ext>
     </p:extLst>
   </p:cSld>
@@ -8869,8 +9286,13 @@
           <a:p>
             <a:r>
               <a:rPr lang="bg-BG" dirty="0"/>
-              <a:t>Недостатъци</a:t>
-            </a:r>
+              <a:t>Подобрения </a:t>
+            </a:r>
+            <a:r>
+              <a:rPr lang="en-US" dirty="0"/>
+              <a:t>// TODO – maybe change title</a:t>
+            </a:r>
+            <a:endParaRPr lang="bg-BG" dirty="0"/>
           </a:p>
         </p:txBody>
       </p:sp>
@@ -8884,12 +9306,7 @@
             <p:ph idx="1"/>
           </p:nvPr>
         </p:nvSpPr>
-        <p:spPr>
-          <a:xfrm>
-            <a:off x="2592925" y="2282890"/>
-            <a:ext cx="8915400" cy="3777622"/>
-          </a:xfrm>
-        </p:spPr>
+        <p:spPr/>
         <p:txBody>
           <a:bodyPr/>
           <a:lstStyle/>
@@ -8899,36 +9316,44 @@
               <a:buChar char="Ø"/>
             </a:pPr>
             <a:r>
-              <a:rPr lang="ru-RU" dirty="0" err="1"/>
-              <a:t>Някои</a:t>
-            </a:r>
-            <a:r>
-              <a:rPr lang="ru-RU" dirty="0"/>
-              <a:t> PDF </a:t>
-            </a:r>
-            <a:r>
-              <a:rPr lang="ru-RU" dirty="0" err="1"/>
-              <a:t>файлове</a:t>
-            </a:r>
-            <a:r>
-              <a:rPr lang="ru-RU" dirty="0"/>
-              <a:t> се </a:t>
-            </a:r>
-            <a:r>
-              <a:rPr lang="ru-RU" dirty="0" err="1"/>
-              <a:t>извличат</a:t>
-            </a:r>
-            <a:r>
-              <a:rPr lang="ru-RU" dirty="0"/>
-              <a:t> </a:t>
-            </a:r>
-            <a:r>
-              <a:rPr lang="ru-RU" dirty="0" err="1"/>
-              <a:t>лошо</a:t>
-            </a:r>
-            <a:r>
-              <a:rPr lang="ru-RU" dirty="0"/>
-              <a:t>. </a:t>
+              <a:rPr lang="bg-BG" dirty="0"/>
+              <a:t>Използване на модел</a:t>
+            </a:r>
+            <a:r>
+              <a:rPr lang="en-US" dirty="0"/>
+              <a:t> (TODO: </a:t>
+            </a:r>
+            <a:r>
+              <a:rPr lang="bg-BG" dirty="0"/>
+              <a:t>Сами – подробности </a:t>
+            </a:r>
+            <a:r>
+              <a:rPr lang="en-US" dirty="0" err="1"/>
+              <a:t>pls</a:t>
+            </a:r>
+            <a:r>
+              <a:rPr lang="en-US" dirty="0"/>
+              <a:t>)</a:t>
+            </a:r>
+            <a:r>
+              <a:rPr lang="bg-BG" dirty="0"/>
+              <a:t> за изчистване на данните </a:t>
+            </a:r>
+            <a:r>
+              <a:rPr lang="en-US" dirty="0"/>
+              <a:t>(</a:t>
+            </a:r>
+            <a:r>
+              <a:rPr lang="bg-BG" dirty="0"/>
+              <a:t>скъпо</a:t>
+            </a:r>
+            <a:r>
+              <a:rPr lang="en-US" dirty="0"/>
+              <a:t>)</a:t>
+            </a:r>
+            <a:r>
+              <a:rPr lang="bg-BG" dirty="0"/>
+              <a:t>.</a:t>
             </a:r>
           </a:p>
           <a:p>
@@ -8937,50 +9362,16 @@
               <a:buChar char="Ø"/>
             </a:pPr>
             <a:r>
-              <a:rPr lang="ru-RU" dirty="0" err="1"/>
-              <a:t>Системата</a:t>
-            </a:r>
-            <a:r>
-              <a:rPr lang="ru-RU" dirty="0"/>
-              <a:t> не </a:t>
-            </a:r>
-            <a:r>
-              <a:rPr lang="ru-RU" dirty="0" err="1"/>
-              <a:t>замества</a:t>
-            </a:r>
-            <a:r>
-              <a:rPr lang="ru-RU" dirty="0"/>
-              <a:t> </a:t>
-            </a:r>
-            <a:r>
-              <a:rPr lang="ru-RU" dirty="0" err="1"/>
-              <a:t>лекар</a:t>
-            </a:r>
-            <a:r>
-              <a:rPr lang="ru-RU" dirty="0"/>
-              <a:t>. </a:t>
-            </a:r>
-          </a:p>
-          <a:p>
-            <a:pPr>
-              <a:buFont typeface="Wingdings" panose="05000000000000000000" pitchFamily="2" charset="2"/>
-              <a:buChar char="Ø"/>
-            </a:pPr>
-            <a:r>
-              <a:rPr lang="ru-RU" dirty="0" err="1"/>
-              <a:t>Възможни</a:t>
-            </a:r>
-            <a:r>
-              <a:rPr lang="ru-RU" dirty="0"/>
-              <a:t> </a:t>
-            </a:r>
-            <a:r>
-              <a:rPr lang="ru-RU" dirty="0" err="1"/>
-              <a:t>халюцинации</a:t>
-            </a:r>
-            <a:r>
-              <a:rPr lang="ru-RU" dirty="0"/>
-              <a:t> на LLM.</a:t>
+              <a:rPr lang="bg-BG" dirty="0"/>
+              <a:t>Използване на генеративни модели</a:t>
+            </a:r>
+            <a:r>
+              <a:rPr lang="en-US" dirty="0"/>
+              <a:t>, </a:t>
+            </a:r>
+            <a:r>
+              <a:rPr lang="bg-BG" dirty="0"/>
+              <a:t>които са по-добре тренирани върху български език.</a:t>
             </a:r>
           </a:p>
         </p:txBody>
@@ -8988,7 +9379,7 @@
     </p:spTree>
     <p:extLst>
       <p:ext uri="{BB962C8B-B14F-4D97-AF65-F5344CB8AC3E}">
-        <p14:creationId xmlns:p14="http://schemas.microsoft.com/office/powerpoint/2010/main" val="664100836"/>
+        <p14:creationId xmlns:p14="http://schemas.microsoft.com/office/powerpoint/2010/main" val="1686784207"/>
       </p:ext>
     </p:extLst>
   </p:cSld>
@@ -9022,7 +9413,7 @@
             <a:spLocks noGrp="1"/>
           </p:cNvSpPr>
           <p:nvPr>
-            <p:ph type="title"/>
+            <p:ph type="ctrTitle"/>
           </p:nvPr>
         </p:nvSpPr>
         <p:spPr/>
@@ -9032,92 +9423,7 @@
           <a:p>
             <a:r>
               <a:rPr lang="bg-BG" dirty="0"/>
-              <a:t>Подобрения </a:t>
-            </a:r>
-            <a:r>
-              <a:rPr lang="en-US" dirty="0"/>
-              <a:t>// TODO – maybe change title</a:t>
-            </a:r>
-            <a:endParaRPr lang="bg-BG" dirty="0"/>
-          </a:p>
-        </p:txBody>
-      </p:sp>
-      <p:sp>
-        <p:nvSpPr>
-          <p:cNvPr id="3" name="Content Placeholder 2"/>
-          <p:cNvSpPr>
-            <a:spLocks noGrp="1"/>
-          </p:cNvSpPr>
-          <p:nvPr>
-            <p:ph idx="1"/>
-          </p:nvPr>
-        </p:nvSpPr>
-        <p:spPr/>
-        <p:txBody>
-          <a:bodyPr/>
-          <a:lstStyle/>
-          <a:p>
-            <a:pPr>
-              <a:buFont typeface="Wingdings" panose="05000000000000000000" pitchFamily="2" charset="2"/>
-              <a:buChar char="Ø"/>
-            </a:pPr>
-            <a:r>
-              <a:rPr lang="bg-BG" dirty="0"/>
-              <a:t>Използване на модел</a:t>
-            </a:r>
-            <a:r>
-              <a:rPr lang="en-US" dirty="0"/>
-              <a:t> (TODO: </a:t>
-            </a:r>
-            <a:r>
-              <a:rPr lang="bg-BG" dirty="0"/>
-              <a:t>Сами – подробности </a:t>
-            </a:r>
-            <a:r>
-              <a:rPr lang="en-US" dirty="0" err="1"/>
-              <a:t>pls</a:t>
-            </a:r>
-            <a:r>
-              <a:rPr lang="en-US" dirty="0"/>
-              <a:t>)</a:t>
-            </a:r>
-            <a:r>
-              <a:rPr lang="bg-BG" dirty="0"/>
-              <a:t> за изчистване на данните </a:t>
-            </a:r>
-            <a:r>
-              <a:rPr lang="en-US" dirty="0"/>
-              <a:t>(</a:t>
-            </a:r>
-            <a:r>
-              <a:rPr lang="bg-BG" dirty="0"/>
-              <a:t>скъпо</a:t>
-            </a:r>
-            <a:r>
-              <a:rPr lang="en-US" dirty="0"/>
-              <a:t>)</a:t>
-            </a:r>
-            <a:r>
-              <a:rPr lang="bg-BG" dirty="0"/>
-              <a:t>.</a:t>
-            </a:r>
-          </a:p>
-          <a:p>
-            <a:pPr>
-              <a:buFont typeface="Wingdings" panose="05000000000000000000" pitchFamily="2" charset="2"/>
-              <a:buChar char="Ø"/>
-            </a:pPr>
-            <a:r>
-              <a:rPr lang="bg-BG" dirty="0"/>
-              <a:t>Използване на генеративни модели</a:t>
-            </a:r>
-            <a:r>
-              <a:rPr lang="en-US" dirty="0"/>
-              <a:t>, </a:t>
-            </a:r>
-            <a:r>
-              <a:rPr lang="bg-BG" dirty="0"/>
-              <a:t>които са по-добре тренирани върху български език.</a:t>
+              <a:t>Демонстрация</a:t>
             </a:r>
           </a:p>
         </p:txBody>
@@ -9125,7 +9431,7 @@
     </p:spTree>
     <p:extLst>
       <p:ext uri="{BB962C8B-B14F-4D97-AF65-F5344CB8AC3E}">
-        <p14:creationId xmlns:p14="http://schemas.microsoft.com/office/powerpoint/2010/main" val="1686784207"/>
+        <p14:creationId xmlns:p14="http://schemas.microsoft.com/office/powerpoint/2010/main" val="4180439655"/>
       </p:ext>
     </p:extLst>
   </p:cSld>
@@ -9169,58 +9475,6 @@
           <a:p>
             <a:r>
               <a:rPr lang="bg-BG" dirty="0"/>
-              <a:t>Демонстрация</a:t>
-            </a:r>
-          </a:p>
-        </p:txBody>
-      </p:sp>
-    </p:spTree>
-    <p:extLst>
-      <p:ext uri="{BB962C8B-B14F-4D97-AF65-F5344CB8AC3E}">
-        <p14:creationId xmlns:p14="http://schemas.microsoft.com/office/powerpoint/2010/main" val="4180439655"/>
-      </p:ext>
-    </p:extLst>
-  </p:cSld>
-  <p:clrMapOvr>
-    <a:masterClrMapping/>
-  </p:clrMapOvr>
-</p:sld>
-</file>
-
-<file path=ppt/slides/slide17.xml><?xml version="1.0" encoding="utf-8"?>
-<p:sld xmlns:a="http://schemas.openxmlformats.org/drawingml/2006/main" xmlns:r="http://schemas.openxmlformats.org/officeDocument/2006/relationships" xmlns:p="http://schemas.openxmlformats.org/presentationml/2006/main">
-  <p:cSld>
-    <p:spTree>
-      <p:nvGrpSpPr>
-        <p:cNvPr id="1" name=""/>
-        <p:cNvGrpSpPr/>
-        <p:nvPr/>
-      </p:nvGrpSpPr>
-      <p:grpSpPr>
-        <a:xfrm>
-          <a:off x="0" y="0"/>
-          <a:ext cx="0" cy="0"/>
-          <a:chOff x="0" y="0"/>
-          <a:chExt cx="0" cy="0"/>
-        </a:xfrm>
-      </p:grpSpPr>
-      <p:sp>
-        <p:nvSpPr>
-          <p:cNvPr id="2" name="Title 1"/>
-          <p:cNvSpPr>
-            <a:spLocks noGrp="1"/>
-          </p:cNvSpPr>
-          <p:nvPr>
-            <p:ph type="ctrTitle"/>
-          </p:nvPr>
-        </p:nvSpPr>
-        <p:spPr/>
-        <p:txBody>
-          <a:bodyPr/>
-          <a:lstStyle/>
-          <a:p>
-            <a:r>
-              <a:rPr lang="bg-BG" dirty="0"/>
               <a:t>Благодарим за вниманието!</a:t>
             </a:r>
           </a:p>
@@ -9236,13 +9490,13 @@
   <p:clrMapOvr>
     <a:masterClrMapping/>
   </p:clrMapOvr>
-  <mc:AlternateContent xmlns:mc="http://schemas.openxmlformats.org/markup-compatibility/2006">
-    <mc:Choice xmlns:p15="http://schemas.microsoft.com/office/powerpoint/2012/main" Requires="p15">
+  <mc:AlternateContent xmlns:mc="http://schemas.openxmlformats.org/markup-compatibility/2006" xmlns:p15="http://schemas.microsoft.com/office/powerpoint/2012/main">
+    <mc:Choice Requires="p15">
       <p:transition xmlns:p14="http://schemas.microsoft.com/office/powerpoint/2010/main" spd="slow" p14:dur="4000">
         <p15:prstTrans prst="curtains"/>
       </p:transition>
     </mc:Choice>
-    <mc:Fallback>
+    <mc:Fallback xmlns="">
       <p:transition spd="slow">
         <p:fade/>
       </p:transition>
@@ -10389,7 +10643,7 @@
     <a:masterClrMapping/>
   </p:clrMapOvr>
   <mc:AlternateContent xmlns:mc="http://schemas.openxmlformats.org/markup-compatibility/2006">
-    <mc:Choice xmlns:p159="http://schemas.microsoft.com/office/powerpoint/2015/09/main" Requires="p159">
+    <mc:Choice xmlns:p159="http://schemas.microsoft.com/office/powerpoint/2015/09/main" xmlns="" Requires="p159">
       <p:transition xmlns:p14="http://schemas.microsoft.com/office/powerpoint/2010/main" spd="slow" p14:dur="2000">
         <p159:morph option="byObject"/>
       </p:transition>
@@ -10719,13 +10973,13 @@
   <p:clrMapOvr>
     <a:masterClrMapping/>
   </p:clrMapOvr>
-  <mc:AlternateContent xmlns:mc="http://schemas.openxmlformats.org/markup-compatibility/2006">
-    <mc:Choice xmlns:p15="http://schemas.microsoft.com/office/powerpoint/2012/main" Requires="p15">
+  <mc:AlternateContent xmlns:mc="http://schemas.openxmlformats.org/markup-compatibility/2006" xmlns:p15="http://schemas.microsoft.com/office/powerpoint/2012/main">
+    <mc:Choice Requires="p15">
       <p:transition xmlns:p14="http://schemas.microsoft.com/office/powerpoint/2010/main" spd="slow" p14:dur="1250">
         <p15:prstTrans prst="pageCurlDouble"/>
       </p:transition>
     </mc:Choice>
-    <mc:Fallback>
+    <mc:Fallback xmlns="">
       <p:transition spd="slow">
         <p:fade/>
       </p:transition>
@@ -11164,13 +11418,13 @@
   <p:clrMapOvr>
     <a:masterClrMapping/>
   </p:clrMapOvr>
-  <mc:AlternateContent xmlns:mc="http://schemas.openxmlformats.org/markup-compatibility/2006">
-    <mc:Choice xmlns:p15="http://schemas.microsoft.com/office/powerpoint/2012/main" Requires="p15">
+  <mc:AlternateContent xmlns:mc="http://schemas.openxmlformats.org/markup-compatibility/2006" xmlns:p15="http://schemas.microsoft.com/office/powerpoint/2012/main">
+    <mc:Choice Requires="p15">
       <p:transition xmlns:p14="http://schemas.microsoft.com/office/powerpoint/2010/main" spd="slow" p14:dur="1250">
         <p15:prstTrans prst="pageCurlDouble"/>
       </p:transition>
     </mc:Choice>
-    <mc:Fallback>
+    <mc:Fallback xmlns="">
       <p:transition spd="slow">
         <p:fade/>
       </p:transition>
@@ -11327,13 +11581,13 @@
   <p:clrMapOvr>
     <a:masterClrMapping/>
   </p:clrMapOvr>
-  <mc:AlternateContent xmlns:mc="http://schemas.openxmlformats.org/markup-compatibility/2006">
-    <mc:Choice xmlns:p15="http://schemas.microsoft.com/office/powerpoint/2012/main" Requires="p15">
+  <mc:AlternateContent xmlns:mc="http://schemas.openxmlformats.org/markup-compatibility/2006" xmlns:p15="http://schemas.microsoft.com/office/powerpoint/2012/main">
+    <mc:Choice Requires="p15">
       <p:transition xmlns:p14="http://schemas.microsoft.com/office/powerpoint/2010/main" spd="slow" p14:dur="1250">
         <p15:prstTrans prst="pageCurlDouble"/>
       </p:transition>
     </mc:Choice>
-    <mc:Fallback>
+    <mc:Fallback xmlns="">
       <p:transition spd="slow">
         <p:fade/>
       </p:transition>

</xml_diff>

<commit_message>
minor changes in split_texts.py and presentation
</commit_message>
<xml_diff>
--- a/rag_presentation.pptx
+++ b/rag_presentation.pptx
@@ -315,7 +315,7 @@
           <a:p>
             <a:fld id="{27B09BD0-848F-4EBB-A109-7353F2339BC4}" type="datetimeFigureOut">
               <a:rPr lang="bg-BG" smtClean="0"/>
-              <a:t>10.6.2026 г.</a:t>
+              <a:t>11.6.2026 г.</a:t>
             </a:fld>
             <a:endParaRPr lang="bg-BG"/>
           </a:p>
@@ -660,7 +660,7 @@
           <a:p>
             <a:fld id="{27B09BD0-848F-4EBB-A109-7353F2339BC4}" type="datetimeFigureOut">
               <a:rPr lang="bg-BG" smtClean="0"/>
-              <a:t>10.6.2026 г.</a:t>
+              <a:t>11.6.2026 г.</a:t>
             </a:fld>
             <a:endParaRPr lang="bg-BG"/>
           </a:p>
@@ -1061,7 +1061,7 @@
           <a:p>
             <a:fld id="{27B09BD0-848F-4EBB-A109-7353F2339BC4}" type="datetimeFigureOut">
               <a:rPr lang="bg-BG" smtClean="0"/>
-              <a:t>10.6.2026 г.</a:t>
+              <a:t>11.6.2026 г.</a:t>
             </a:fld>
             <a:endParaRPr lang="bg-BG"/>
           </a:p>
@@ -1397,7 +1397,7 @@
           <a:p>
             <a:fld id="{27B09BD0-848F-4EBB-A109-7353F2339BC4}" type="datetimeFigureOut">
               <a:rPr lang="bg-BG" smtClean="0"/>
-              <a:t>10.6.2026 г.</a:t>
+              <a:t>11.6.2026 г.</a:t>
             </a:fld>
             <a:endParaRPr lang="bg-BG"/>
           </a:p>
@@ -1717,7 +1717,7 @@
           <a:p>
             <a:fld id="{27B09BD0-848F-4EBB-A109-7353F2339BC4}" type="datetimeFigureOut">
               <a:rPr lang="bg-BG" smtClean="0"/>
-              <a:t>10.6.2026 г.</a:t>
+              <a:t>11.6.2026 г.</a:t>
             </a:fld>
             <a:endParaRPr lang="bg-BG"/>
           </a:p>
@@ -2113,7 +2113,7 @@
           <a:p>
             <a:fld id="{27B09BD0-848F-4EBB-A109-7353F2339BC4}" type="datetimeFigureOut">
               <a:rPr lang="bg-BG" smtClean="0"/>
-              <a:t>10.6.2026 г.</a:t>
+              <a:t>11.6.2026 г.</a:t>
             </a:fld>
             <a:endParaRPr lang="bg-BG"/>
           </a:p>
@@ -2370,7 +2370,7 @@
           <a:p>
             <a:fld id="{27B09BD0-848F-4EBB-A109-7353F2339BC4}" type="datetimeFigureOut">
               <a:rPr lang="bg-BG" smtClean="0"/>
-              <a:t>10.6.2026 г.</a:t>
+              <a:t>11.6.2026 г.</a:t>
             </a:fld>
             <a:endParaRPr lang="bg-BG"/>
           </a:p>
@@ -2632,7 +2632,7 @@
           <a:p>
             <a:fld id="{27B09BD0-848F-4EBB-A109-7353F2339BC4}" type="datetimeFigureOut">
               <a:rPr lang="bg-BG" smtClean="0"/>
-              <a:t>10.6.2026 г.</a:t>
+              <a:t>11.6.2026 г.</a:t>
             </a:fld>
             <a:endParaRPr lang="bg-BG"/>
           </a:p>
@@ -2894,7 +2894,7 @@
           <a:p>
             <a:fld id="{27B09BD0-848F-4EBB-A109-7353F2339BC4}" type="datetimeFigureOut">
               <a:rPr lang="bg-BG" smtClean="0"/>
-              <a:t>10.6.2026 г.</a:t>
+              <a:t>11.6.2026 г.</a:t>
             </a:fld>
             <a:endParaRPr lang="bg-BG"/>
           </a:p>
@@ -3230,7 +3230,7 @@
           <a:p>
             <a:fld id="{27B09BD0-848F-4EBB-A109-7353F2339BC4}" type="datetimeFigureOut">
               <a:rPr lang="bg-BG" smtClean="0"/>
-              <a:t>10.6.2026 г.</a:t>
+              <a:t>11.6.2026 г.</a:t>
             </a:fld>
             <a:endParaRPr lang="bg-BG"/>
           </a:p>
@@ -3553,7 +3553,7 @@
           <a:p>
             <a:fld id="{27B09BD0-848F-4EBB-A109-7353F2339BC4}" type="datetimeFigureOut">
               <a:rPr lang="bg-BG" smtClean="0"/>
-              <a:t>10.6.2026 г.</a:t>
+              <a:t>11.6.2026 г.</a:t>
             </a:fld>
             <a:endParaRPr lang="bg-BG"/>
           </a:p>
@@ -4017,7 +4017,7 @@
           <a:p>
             <a:fld id="{27B09BD0-848F-4EBB-A109-7353F2339BC4}" type="datetimeFigureOut">
               <a:rPr lang="bg-BG" smtClean="0"/>
-              <a:t>10.6.2026 г.</a:t>
+              <a:t>11.6.2026 г.</a:t>
             </a:fld>
             <a:endParaRPr lang="bg-BG"/>
           </a:p>
@@ -4229,7 +4229,7 @@
           <a:p>
             <a:fld id="{27B09BD0-848F-4EBB-A109-7353F2339BC4}" type="datetimeFigureOut">
               <a:rPr lang="bg-BG" smtClean="0"/>
-              <a:t>10.6.2026 г.</a:t>
+              <a:t>11.6.2026 г.</a:t>
             </a:fld>
             <a:endParaRPr lang="bg-BG"/>
           </a:p>
@@ -4406,7 +4406,7 @@
           <a:p>
             <a:fld id="{27B09BD0-848F-4EBB-A109-7353F2339BC4}" type="datetimeFigureOut">
               <a:rPr lang="bg-BG" smtClean="0"/>
-              <a:t>10.6.2026 г.</a:t>
+              <a:t>11.6.2026 г.</a:t>
             </a:fld>
             <a:endParaRPr lang="bg-BG"/>
           </a:p>
@@ -4739,7 +4739,7 @@
           <a:p>
             <a:fld id="{27B09BD0-848F-4EBB-A109-7353F2339BC4}" type="datetimeFigureOut">
               <a:rPr lang="bg-BG" smtClean="0"/>
-              <a:t>10.6.2026 г.</a:t>
+              <a:t>11.6.2026 г.</a:t>
             </a:fld>
             <a:endParaRPr lang="bg-BG"/>
           </a:p>
@@ -5084,7 +5084,7 @@
           <a:p>
             <a:fld id="{27B09BD0-848F-4EBB-A109-7353F2339BC4}" type="datetimeFigureOut">
               <a:rPr lang="bg-BG" smtClean="0"/>
-              <a:t>10.6.2026 г.</a:t>
+              <a:t>11.6.2026 г.</a:t>
             </a:fld>
             <a:endParaRPr lang="bg-BG"/>
           </a:p>
@@ -7376,7 +7376,7 @@
           <a:p>
             <a:fld id="{27B09BD0-848F-4EBB-A109-7353F2339BC4}" type="datetimeFigureOut">
               <a:rPr lang="bg-BG" smtClean="0"/>
-              <a:t>10.6.2026 г.</a:t>
+              <a:t>11.6.2026 г.</a:t>
             </a:fld>
             <a:endParaRPr lang="bg-BG"/>
           </a:p>
@@ -7982,11 +7982,11 @@
   <p:clrMapOvr>
     <a:masterClrMapping/>
   </p:clrMapOvr>
-  <mc:AlternateContent xmlns:mc="http://schemas.openxmlformats.org/markup-compatibility/2006">
-    <mc:Choice xmlns:p14="http://schemas.microsoft.com/office/powerpoint/2010/main" Requires="p14">
+  <mc:AlternateContent xmlns:mc="http://schemas.openxmlformats.org/markup-compatibility/2006" xmlns:p14="http://schemas.microsoft.com/office/powerpoint/2010/main">
+    <mc:Choice Requires="p14">
       <p:transition spd="slow" p14:dur="2000"/>
     </mc:Choice>
-    <mc:Fallback>
+    <mc:Fallback xmlns="">
       <p:transition spd="slow"/>
     </mc:Fallback>
   </mc:AlternateContent>
@@ -8152,14 +8152,14 @@
             <p:ph idx="1"/>
             <p:extLst>
               <p:ext uri="{D42A27DB-BD31-4B8C-83A1-F6EECF244321}">
-                <p14:modId xmlns:p14="http://schemas.microsoft.com/office/powerpoint/2010/main" val="59626609"/>
+                <p14:modId xmlns:p14="http://schemas.microsoft.com/office/powerpoint/2010/main" val="3602940691"/>
               </p:ext>
             </p:extLst>
           </p:nvPr>
         </p:nvGraphicFramePr>
         <p:xfrm>
           <a:off x="2132013" y="1443134"/>
-          <a:ext cx="8915400" cy="4635538"/>
+          <a:ext cx="8915400" cy="4867914"/>
         </p:xfrm>
         <a:graphic>
           <a:graphicData uri="http://schemas.openxmlformats.org/drawingml/2006/table">
@@ -8308,85 +8308,6 @@
                   </a:ext>
                 </a:extLst>
               </a:tr>
-              <a:tr h="682024">
-                <a:tc>
-                  <a:txBody>
-                    <a:bodyPr/>
-                    <a:lstStyle/>
-                    <a:p>
-                      <a:r>
-                        <a:rPr lang="en-US" dirty="0" err="1"/>
-                        <a:t>RapidFuzz</a:t>
-                      </a:r>
-                      <a:endParaRPr lang="bg-BG" dirty="0"/>
-                    </a:p>
-                  </a:txBody>
-                  <a:tcPr/>
-                </a:tc>
-                <a:tc>
-                  <a:txBody>
-                    <a:bodyPr/>
-                    <a:lstStyle/>
-                    <a:p>
-                      <a:r>
-                        <a:rPr lang="ru-RU" dirty="0" err="1"/>
-                        <a:t>Използван</a:t>
-                      </a:r>
-                      <a:r>
-                        <a:rPr lang="ru-RU" dirty="0"/>
-                        <a:t> за </a:t>
-                      </a:r>
-                      <a:r>
-                        <a:rPr lang="ru-RU" dirty="0" err="1"/>
-                        <a:t>fuzzy</a:t>
-                      </a:r>
-                      <a:r>
-                        <a:rPr lang="ru-RU" dirty="0"/>
-                        <a:t> </a:t>
-                      </a:r>
-                      <a:r>
-                        <a:rPr lang="ru-RU" dirty="0" err="1"/>
-                        <a:t>matching</a:t>
-                      </a:r>
-                      <a:r>
-                        <a:rPr lang="ru-RU" dirty="0"/>
-                        <a:t> на </a:t>
-                      </a:r>
-                      <a:r>
-                        <a:rPr lang="ru-RU" dirty="0" err="1"/>
-                        <a:t>заглавията</a:t>
-                      </a:r>
-                      <a:r>
-                        <a:rPr lang="ru-RU" dirty="0"/>
-                        <a:t> на </a:t>
-                      </a:r>
-                      <a:r>
-                        <a:rPr lang="ru-RU" dirty="0" err="1"/>
-                        <a:t>секциите</a:t>
-                      </a:r>
-                      <a:r>
-                        <a:rPr lang="ru-RU" dirty="0"/>
-                        <a:t> при грешки от </a:t>
-                      </a:r>
-                      <a:r>
-                        <a:rPr lang="ru-RU" dirty="0" err="1"/>
-                        <a:t>извличането</a:t>
-                      </a:r>
-                      <a:r>
-                        <a:rPr lang="ru-RU" dirty="0"/>
-                        <a:t> на текста от PDF.</a:t>
-                      </a:r>
-                      <a:endParaRPr lang="bg-BG" dirty="0"/>
-                    </a:p>
-                  </a:txBody>
-                  <a:tcPr/>
-                </a:tc>
-                <a:extLst>
-                  <a:ext uri="{0D108BD9-81ED-4DB2-BD59-A6C34878D82A}">
-                    <a16:rowId xmlns:a16="http://schemas.microsoft.com/office/drawing/2014/main" val="236891559"/>
-                  </a:ext>
-                </a:extLst>
-              </a:tr>
               <a:tr h="658919">
                 <a:tc>
                   <a:txBody>
@@ -8464,9 +8385,128 @@
                     <a:bodyPr/>
                     <a:lstStyle/>
                     <a:p>
+                      <a:pPr marL="0" marR="0" indent="0" algn="l" defTabSz="457200" rtl="0" eaLnBrk="1" fontAlgn="auto" latinLnBrk="0" hangingPunct="1">
+                        <a:lnSpc>
+                          <a:spcPct val="100000"/>
+                        </a:lnSpc>
+                        <a:spcBef>
+                          <a:spcPts val="0"/>
+                        </a:spcBef>
+                        <a:spcAft>
+                          <a:spcPts val="0"/>
+                        </a:spcAft>
+                        <a:buClrTx/>
+                        <a:buSzTx/>
+                        <a:buFontTx/>
+                        <a:buNone/>
+                        <a:tabLst/>
+                        <a:defRPr/>
+                      </a:pPr>
                       <a:r>
-                        <a:rPr lang="en-US" dirty="0"/>
-                        <a:t>…</a:t>
+                        <a:rPr lang="en-US" dirty="0" err="1" smtClean="0"/>
+                        <a:t>RapidFuzz</a:t>
+                      </a:r>
+                      <a:endParaRPr lang="bg-BG" dirty="0" smtClean="0"/>
+                    </a:p>
+                    <a:p>
+                      <a:endParaRPr lang="bg-BG" dirty="0"/>
+                    </a:p>
+                  </a:txBody>
+                  <a:tcPr/>
+                </a:tc>
+                <a:tc>
+                  <a:txBody>
+                    <a:bodyPr/>
+                    <a:lstStyle/>
+                    <a:p>
+                      <a:pPr marL="0" marR="0" indent="0" algn="l" defTabSz="457200" rtl="0" eaLnBrk="1" fontAlgn="auto" latinLnBrk="0" hangingPunct="1">
+                        <a:lnSpc>
+                          <a:spcPct val="100000"/>
+                        </a:lnSpc>
+                        <a:spcBef>
+                          <a:spcPts val="0"/>
+                        </a:spcBef>
+                        <a:spcAft>
+                          <a:spcPts val="0"/>
+                        </a:spcAft>
+                        <a:buClrTx/>
+                        <a:buSzTx/>
+                        <a:buFontTx/>
+                        <a:buNone/>
+                        <a:tabLst/>
+                        <a:defRPr/>
+                      </a:pPr>
+                      <a:r>
+                        <a:rPr lang="ru-RU" dirty="0" err="1" smtClean="0"/>
+                        <a:t>Използван</a:t>
+                      </a:r>
+                      <a:r>
+                        <a:rPr lang="ru-RU" dirty="0" smtClean="0"/>
+                        <a:t> за </a:t>
+                      </a:r>
+                      <a:r>
+                        <a:rPr lang="ru-RU" dirty="0" err="1" smtClean="0"/>
+                        <a:t>fuzzy</a:t>
+                      </a:r>
+                      <a:r>
+                        <a:rPr lang="ru-RU" dirty="0" smtClean="0"/>
+                        <a:t> </a:t>
+                      </a:r>
+                      <a:r>
+                        <a:rPr lang="ru-RU" dirty="0" err="1" smtClean="0"/>
+                        <a:t>matching</a:t>
+                      </a:r>
+                      <a:r>
+                        <a:rPr lang="ru-RU" dirty="0" smtClean="0"/>
+                        <a:t> на </a:t>
+                      </a:r>
+                      <a:r>
+                        <a:rPr lang="ru-RU" dirty="0" err="1" smtClean="0"/>
+                        <a:t>заглавията</a:t>
+                      </a:r>
+                      <a:r>
+                        <a:rPr lang="ru-RU" dirty="0" smtClean="0"/>
+                        <a:t> на </a:t>
+                      </a:r>
+                      <a:r>
+                        <a:rPr lang="ru-RU" dirty="0" err="1" smtClean="0"/>
+                        <a:t>секциите</a:t>
+                      </a:r>
+                      <a:r>
+                        <a:rPr lang="ru-RU" dirty="0" smtClean="0"/>
+                        <a:t> при грешки от </a:t>
+                      </a:r>
+                      <a:r>
+                        <a:rPr lang="ru-RU" dirty="0" err="1" smtClean="0"/>
+                        <a:t>извличането</a:t>
+                      </a:r>
+                      <a:r>
+                        <a:rPr lang="ru-RU" dirty="0" smtClean="0"/>
+                        <a:t> на текста от PDF.</a:t>
+                      </a:r>
+                      <a:endParaRPr lang="bg-BG" dirty="0" smtClean="0"/>
+                    </a:p>
+                    <a:p>
+                      <a:endParaRPr lang="bg-BG" dirty="0"/>
+                    </a:p>
+                  </a:txBody>
+                  <a:tcPr/>
+                </a:tc>
+                <a:extLst>
+                  <a:ext uri="{0D108BD9-81ED-4DB2-BD59-A6C34878D82A}">
+                    <a16:rowId xmlns:a16="http://schemas.microsoft.com/office/drawing/2014/main" val="349629430"/>
+                  </a:ext>
+                </a:extLst>
+              </a:tr>
+              <a:tr h="658919">
+                <a:tc>
+                  <a:txBody>
+                    <a:bodyPr/>
+                    <a:lstStyle/>
+                    <a:p>
+                      <a:r>
+                        <a:rPr lang="en-US" dirty="0" smtClean="0"/>
+                        <a:t>FAISS</a:t>
                       </a:r>
                       <a:endParaRPr lang="bg-BG" dirty="0"/>
                     </a:p>
@@ -8479,17 +8519,25 @@
                     <a:lstStyle/>
                     <a:p>
                       <a:r>
-                        <a:rPr lang="en-US" dirty="0"/>
-                        <a:t>…</a:t>
+                        <a:rPr lang="bg-BG" dirty="0" smtClean="0"/>
+                        <a:t>Индексиране и бързо семантично търсене на векторни </a:t>
+                      </a:r>
+                      <a:r>
+                        <a:rPr lang="en-US" dirty="0" err="1" smtClean="0"/>
+                        <a:t>embeddings</a:t>
+                      </a:r>
+                      <a:r>
+                        <a:rPr lang="bg-BG" dirty="0" smtClean="0"/>
+                        <a:t>.</a:t>
                       </a:r>
                       <a:endParaRPr lang="bg-BG" dirty="0"/>
                     </a:p>
                   </a:txBody>
-                  <a:tcPr/>
+                  <a:tcPr anchor="ctr"/>
                 </a:tc>
                 <a:extLst>
                   <a:ext uri="{0D108BD9-81ED-4DB2-BD59-A6C34878D82A}">
-                    <a16:rowId xmlns:a16="http://schemas.microsoft.com/office/drawing/2014/main" val="349629430"/>
+                    <a16:rowId xmlns:a16="http://schemas.microsoft.com/office/drawing/2014/main" val="583457024"/>
                   </a:ext>
                 </a:extLst>
               </a:tr>
@@ -8509,14 +8557,14 @@
                     <a:bodyPr/>
                     <a:lstStyle/>
                     <a:p>
-                      <a:endParaRPr lang="bg-BG"/>
+                      <a:endParaRPr lang="bg-BG" dirty="0"/>
                     </a:p>
                   </a:txBody>
                   <a:tcPr/>
                 </a:tc>
                 <a:extLst>
                   <a:ext uri="{0D108BD9-81ED-4DB2-BD59-A6C34878D82A}">
-                    <a16:rowId xmlns:a16="http://schemas.microsoft.com/office/drawing/2014/main" val="583457024"/>
+                    <a16:rowId xmlns:a16="http://schemas.microsoft.com/office/drawing/2014/main" val="3822034256"/>
                   </a:ext>
                 </a:extLst>
               </a:tr>
@@ -8543,7 +8591,7 @@
                 </a:tc>
                 <a:extLst>
                   <a:ext uri="{0D108BD9-81ED-4DB2-BD59-A6C34878D82A}">
-                    <a16:rowId xmlns:a16="http://schemas.microsoft.com/office/drawing/2014/main" val="3822034256"/>
+                    <a16:rowId xmlns:a16="http://schemas.microsoft.com/office/drawing/2014/main" val="1382405623"/>
                   </a:ext>
                 </a:extLst>
               </a:tr>
@@ -10643,7 +10691,7 @@
     <a:masterClrMapping/>
   </p:clrMapOvr>
   <mc:AlternateContent xmlns:mc="http://schemas.openxmlformats.org/markup-compatibility/2006">
-    <mc:Choice xmlns:p159="http://schemas.microsoft.com/office/powerpoint/2015/09/main" xmlns="" Requires="p159">
+    <mc:Choice xmlns="" xmlns:p159="http://schemas.microsoft.com/office/powerpoint/2015/09/main" Requires="p159">
       <p:transition xmlns:p14="http://schemas.microsoft.com/office/powerpoint/2010/main" spd="slow" p14:dur="2000">
         <p159:morph option="byObject"/>
       </p:transition>

</xml_diff>